<commit_message>
Update X Family Travelling project
</commit_message>
<xml_diff>
--- a/meeting/Environment and tools(meeting4).pptx
+++ b/meeting/Environment and tools(meeting4).pptx
@@ -4,8 +4,17 @@
   <p:sldMasterIdLst>
     <p:sldMasterId id="2147483648" r:id="rId1"/>
   </p:sldMasterIdLst>
+  <p:notesMasterIdLst>
+    <p:notesMasterId r:id="rId9"/>
+  </p:notesMasterIdLst>
   <p:sldIdLst>
     <p:sldId id="256" r:id="rId2"/>
+    <p:sldId id="258" r:id="rId3"/>
+    <p:sldId id="257" r:id="rId4"/>
+    <p:sldId id="259" r:id="rId5"/>
+    <p:sldId id="260" r:id="rId6"/>
+    <p:sldId id="261" r:id="rId7"/>
+    <p:sldId id="262" r:id="rId8"/>
   </p:sldIdLst>
   <p:sldSz cx="12192000" cy="6858000"/>
   <p:notesSz cx="6858000" cy="9144000"/>
@@ -104,7 +113,894 @@
       </a:defRPr>
     </a:lvl9pPr>
   </p:defaultTextStyle>
+  <p:extLst>
+    <p:ext uri="{EFAFB233-063F-42B5-8137-9DF3F51BA10A}">
+      <p15:sldGuideLst xmlns:p15="http://schemas.microsoft.com/office/powerpoint/2012/main"/>
+    </p:ext>
+  </p:extLst>
 </p:presentation>
+</file>
+
+<file path=ppt/ink/ink1.xml><?xml version="1.0" encoding="utf-8"?>
+<inkml:ink xmlns:inkml="http://www.w3.org/2003/InkML">
+  <inkml:definitions>
+    <inkml:context xml:id="ctx0">
+      <inkml:inkSource xml:id="inkSrc0">
+        <inkml:traceFormat>
+          <inkml:channel name="X" type="integer" min="-2.14748E9" max="2.14748E9" units="cm"/>
+          <inkml:channel name="Y" type="integer" min="-2.14748E9" max="2.14748E9" units="cm"/>
+          <inkml:channel name="F" type="integer" max="32767" units="dev"/>
+        </inkml:traceFormat>
+        <inkml:channelProperties>
+          <inkml:channelProperty channel="X" name="resolution" value="1000" units="1/cm"/>
+          <inkml:channelProperty channel="Y" name="resolution" value="1000" units="1/cm"/>
+          <inkml:channelProperty channel="F" name="resolution" value="0" units="1/dev"/>
+        </inkml:channelProperties>
+      </inkml:inkSource>
+      <inkml:timestamp xml:id="ts0" timeString="2026-09-15T10:54:53.233"/>
+    </inkml:context>
+    <inkml:brush xml:id="br0">
+      <inkml:brushProperty name="width" value="0.035" units="cm"/>
+      <inkml:brushProperty name="height" value="0.035" units="cm"/>
+      <inkml:brushProperty name="color" value="#FF0000"/>
+    </inkml:brush>
+  </inkml:definitions>
+  <inkml:trace contextRef="#ctx0" brushRef="#br0">0 0 24513,'0'1168'0,"5475"-1168"0,-5475-1168 0,-5475 1168 0</inkml:trace>
+</inkml:ink>
+</file>
+
+<file path=ppt/ink/ink10.xml><?xml version="1.0" encoding="utf-8"?>
+<inkml:ink xmlns:inkml="http://www.w3.org/2003/InkML">
+  <inkml:definitions>
+    <inkml:context xml:id="ctx0">
+      <inkml:inkSource xml:id="inkSrc0">
+        <inkml:traceFormat>
+          <inkml:channel name="X" type="integer" min="-2.14748E9" max="2.14748E9" units="cm"/>
+          <inkml:channel name="Y" type="integer" min="-2.14748E9" max="2.14748E9" units="cm"/>
+          <inkml:channel name="F" type="integer" max="32767" units="dev"/>
+        </inkml:traceFormat>
+        <inkml:channelProperties>
+          <inkml:channelProperty channel="X" name="resolution" value="1000" units="1/cm"/>
+          <inkml:channelProperty channel="Y" name="resolution" value="1000" units="1/cm"/>
+          <inkml:channelProperty channel="F" name="resolution" value="0" units="1/dev"/>
+        </inkml:channelProperties>
+      </inkml:inkSource>
+      <inkml:timestamp xml:id="ts0" timeString="2026-09-15T10:49:40.639"/>
+    </inkml:context>
+    <inkml:brush xml:id="br0">
+      <inkml:brushProperty name="width" value="0.035" units="cm"/>
+      <inkml:brushProperty name="height" value="0.035" units="cm"/>
+      <inkml:brushProperty name="color" value="#FF0000"/>
+    </inkml:brush>
+  </inkml:definitions>
+  <inkml:trace contextRef="#ctx0" brushRef="#br0">339 205 24575,'-3'3'0,"0"0"0,0 0 0,0 0 0,0 0 0,1 0 0,-4 7 0,4-7 0,0 0 0,0 0 0,-1 0 0,1 0 0,-1 0 0,0 0 0,-5 4 0,-57 28 0,53-29 0,1 0 0,-1 0 0,1 0 0,1 1 0,0 0 0,-17 16 0,14-8 0,2 1 0,0-1 0,1 1 0,2 1 0,0 0 0,1-1 0,1 2 0,2-1 0,0 0 0,2 1 0,1 28 0,1-40 0,1-1 0,0 1 0,1 0 0,0-1 0,0 1 0,1-1 0,-1 0 0,2 0 0,-1 0 0,1 0 0,0 0 0,1 0 0,-1 0 0,10 6 0,5 1 0,0 0 0,1 0 0,27 11 0,5 2 0,-24-12 0,1-2 0,0 0 0,2-2 0,-1 0 0,2-1 0,-1-1 0,36 4 0,37 9 0,-31-4 0,256 50 0,-257-55 0,0-1 0,126 3 0,411-14 0,-235-1 0,144-16 0,-312 11 0,-38 1 0,-154 5 0,-1-1 0,1 0 0,-1-1 0,0 0 0,0 0 0,0-1 0,-1 0 0,1 0 0,-2-1 0,18-9 0,7-6 0,57-43 0,-81 54 0,-1-1 0,0 0 0,-2-1 0,1 1 0,-2-1 0,0-1 0,-1 1 0,0-1 0,-2 0 0,0 0 0,-1 0 0,3-16 0,0-15 0,-2-1 0,-4-50 0,-2 71 0,-1 0 0,-11-44 0,10 56 0,-2 1 0,0-1 0,0 1 0,-1 0 0,-1 1 0,0-1 0,-1 1 0,-14-14 0,5 8 0,-2 0 0,-36-24 0,47 35 0,0 0 0,0 0 0,-1 0 0,0 0 0,0 1 0,0 0 0,0 0 0,-1 1 0,0 0 0,1 0 0,-12-1 0,-196-28 0,150 19 0,21 6 0,-1 2 0,-74-1 0,-52-4 0,38-2 0,-1 5 0,-149 6 0,-45-1 0,281-2 0,1-2 0,-77-16 0,77 12 0,-1 2 0,-69-5 0,-313 12 0,274 14 0,97-7 0,-84 2 0,121-7 0,1 0 0,0 2 0,0 0 0,0 0 0,1 2 0,0 0 0,-37 14 0,25-8 0,5-3 0,1 2 0,0 0 0,2 1 0,0 1 0,0 0 0,2 1 0,0 1 0,2 1 0,0 0 0,-27 30 0,41-38 0,1 2 0,1-1 0,0 0 0,1 1 0,0 0 0,1-1 0,0 1 0,0 14 0,1-3 0,2 0 0,7 40 0,-3-51 0,0 0 0,1 0 0,1 0 0,0-1 0,0 1 0,2-1 0,0-1 0,0 1 0,1-1 0,17 13 0,7 8 0,-4-3-1365,-4-6-5461</inkml:trace>
+</inkml:ink>
+</file>
+
+<file path=ppt/ink/ink11.xml><?xml version="1.0" encoding="utf-8"?>
+<inkml:ink xmlns:inkml="http://www.w3.org/2003/InkML">
+  <inkml:definitions>
+    <inkml:context xml:id="ctx0">
+      <inkml:inkSource xml:id="inkSrc0">
+        <inkml:traceFormat>
+          <inkml:channel name="X" type="integer" min="-2.14748E9" max="2.14748E9" units="cm"/>
+          <inkml:channel name="Y" type="integer" min="-2.14748E9" max="2.14748E9" units="cm"/>
+          <inkml:channel name="F" type="integer" max="32767" units="dev"/>
+        </inkml:traceFormat>
+        <inkml:channelProperties>
+          <inkml:channelProperty channel="X" name="resolution" value="1000" units="1/cm"/>
+          <inkml:channelProperty channel="Y" name="resolution" value="1000" units="1/cm"/>
+          <inkml:channelProperty channel="F" name="resolution" value="0" units="1/dev"/>
+        </inkml:channelProperties>
+      </inkml:inkSource>
+      <inkml:timestamp xml:id="ts0" timeString="2026-09-16T09:52:20.599"/>
+    </inkml:context>
+    <inkml:brush xml:id="br0">
+      <inkml:brushProperty name="width" value="0.035" units="cm"/>
+      <inkml:brushProperty name="height" value="0.035" units="cm"/>
+      <inkml:brushProperty name="color" value="#FF0000"/>
+    </inkml:brush>
+  </inkml:definitions>
+  <inkml:trace contextRef="#ctx0" brushRef="#br0">7 626 24575,'1886'0'0,"-1830"-3"0,90-15 0,18-2 0,225 17 0,-201 5 0,-182-2 0,1 0 0,-1 0 0,0 0 0,0-1 0,0 0 0,0 0 0,1-1 0,-2 1 0,1-1 0,0-1 0,0 1 0,6-5 0,-8 4 0,-1 0 0,0 0 0,0-1 0,0 0 0,0 1 0,0-1 0,-1 0 0,0 0 0,0 0 0,0-1 0,0 1 0,-1-1 0,1 1 0,-1-1 0,0 1 0,0-10 0,0-8 0,0 0 0,-2 1 0,-1-1 0,0 0 0,-2 1 0,-8-28 0,-6-45 0,17 81 0,-1 0 0,-1 0 0,0 0 0,0 0 0,-1 1 0,-1-1 0,0 1 0,-14-22 0,15 28 0,-1 0 0,1 1 0,-2-1 0,1 1 0,-1 0 0,1 1 0,-1 0 0,0 0 0,-1 0 0,1 0 0,-1 1 0,0 0 0,0 1 0,0-1 0,0 1 0,0 1 0,-11-2 0,-37-2 0,-1 3 0,-87 7 0,21 0 0,-780-5 0,861 2 0,0 2 0,-46 11 0,42-7 0,-68 4 0,-340-11 0,209-3 0,214 4 0,-1 1 0,-51 12 0,-20 3 0,87-17 0,1 1 0,-1 1 0,1 0 0,-1 1 0,1 0 0,-21 10 0,29-11 0,1 0 0,0 1 0,-1 0 0,1-1 0,0 2 0,1-1 0,-1 0 0,1 1 0,0 0 0,0 0 0,1 0 0,-1 1 0,1-1 0,0 1 0,0 0 0,1 0 0,-3 10 0,1 0 11,1 1 0,1 0 0,1-1 0,0 1 1,1 0-1,1 0 0,0 0 0,5 19 0,6 18-482,22 59 1,-26-88-54,3 10-6302</inkml:trace>
+</inkml:ink>
+</file>
+
+<file path=ppt/ink/ink12.xml><?xml version="1.0" encoding="utf-8"?>
+<inkml:ink xmlns:inkml="http://www.w3.org/2003/InkML">
+  <inkml:definitions>
+    <inkml:context xml:id="ctx0">
+      <inkml:inkSource xml:id="inkSrc0">
+        <inkml:traceFormat>
+          <inkml:channel name="X" type="integer" min="-2.14748E9" max="2.14748E9" units="cm"/>
+          <inkml:channel name="Y" type="integer" min="-2.14748E9" max="2.14748E9" units="cm"/>
+          <inkml:channel name="F" type="integer" max="32767" units="dev"/>
+        </inkml:traceFormat>
+        <inkml:channelProperties>
+          <inkml:channelProperty channel="X" name="resolution" value="1000" units="1/cm"/>
+          <inkml:channelProperty channel="Y" name="resolution" value="1000" units="1/cm"/>
+          <inkml:channelProperty channel="F" name="resolution" value="0" units="1/dev"/>
+        </inkml:channelProperties>
+      </inkml:inkSource>
+      <inkml:timestamp xml:id="ts0" timeString="2026-09-16T09:52:35.113"/>
+    </inkml:context>
+    <inkml:brush xml:id="br0">
+      <inkml:brushProperty name="width" value="0.035" units="cm"/>
+      <inkml:brushProperty name="height" value="0.035" units="cm"/>
+      <inkml:brushProperty name="color" value="#FF0000"/>
+    </inkml:brush>
+  </inkml:definitions>
+  <inkml:trace contextRef="#ctx0" brushRef="#br0">53 503 24575,'39'0'0,"0"1"0,0 2 0,45 10 0,-8-2 0,1-2 0,0-4 0,117-7 0,86 5 0,-138 16 0,-81-9 0,64 1 0,548-9 0,-322-5 0,-342 3 0,-1 0 0,1 1 0,0 0 0,-1 0 0,1 1 0,-1 0 0,0 1 0,0-1 0,1 2 0,-2-1 0,1 1 0,0 0 0,-1 1 0,0 0 0,0 0 0,12 11 0,-9-8 0,2 1 0,-1-2 0,1 0 0,0 0 0,1-1 0,0-1 0,0 0 0,0-1 0,0 0 0,0-1 0,1 0 0,15 0 0,-22-2 0,0-1 0,0 0 0,-1 0 0,1 0 0,0-1 0,-1 0 0,1-1 0,0 1 0,-1-1 0,1-1 0,-1 1 0,0-1 0,0 0 0,0 0 0,0-1 0,-1 0 0,1 0 0,-1 0 0,0-1 0,0 0 0,-1 0 0,1 0 0,-1 0 0,0-1 0,6-11 0,0-5 0,-1-1 0,-1 0 0,-2 0 0,0-1 0,-1 0 0,-1 0 0,-1 0 0,-2 0 0,-1-34 0,-2 25 0,-1 1 0,-2-1 0,-1 1 0,-1 0 0,-2 0 0,-19-43 0,25 69 0,0 0 0,0 1 0,-1-1 0,0 1 0,0 0 0,0 0 0,-1 0 0,1 0 0,-1 1 0,0 0 0,-1 0 0,1 0 0,-1 1 0,1 0 0,-1 0 0,0 0 0,0 1 0,-1 0 0,1 0 0,0 0 0,-13-1 0,-11 0 0,0 1 0,0 2 0,-50 6 0,15-2 0,-589 0 0,364-6 0,238 5 0,-88 15 0,82-9 0,-61 2 0,-526-9 0,307-4 0,331 1 0,-1 1 0,1 1 0,0-1 0,-1 1 0,1 1 0,0-1 0,0 1 0,0 1 0,-8 2 0,12-3 0,0 1 0,-1-1 0,2 0 0,-1 1 0,0-1 0,0 1 0,1 0 0,-1 0 0,1 0 0,0 0 0,0 0 0,0 1 0,0-1 0,1 1 0,-1-1 0,1 1 0,0 0 0,0-1 0,0 7 0,-3 16 0,1 0 0,2-1 0,0 1 0,2 0 0,1 0 0,1 0 0,8 32 0,-10-53 5,1 0-1,-1 0 0,1 0 1,1 0-1,-1-1 0,1 1 0,-1-1 1,1 0-1,0 1 0,1-1 1,-1-1-1,1 1 0,0 0 1,0-1-1,0 0 0,0 0 1,0 0-1,1-1 0,-1 1 1,1-1-1,0 0 0,0 0 1,6 1-1,8 1-210,0-1 0,0-2 0,1 1 0,36-4 0,-40 1-233,21 0-6387</inkml:trace>
+</inkml:ink>
+</file>
+
+<file path=ppt/ink/ink13.xml><?xml version="1.0" encoding="utf-8"?>
+<inkml:ink xmlns:inkml="http://www.w3.org/2003/InkML">
+  <inkml:definitions>
+    <inkml:context xml:id="ctx0">
+      <inkml:inkSource xml:id="inkSrc0">
+        <inkml:traceFormat>
+          <inkml:channel name="X" type="integer" min="-2.14748E9" max="2.14748E9" units="cm"/>
+          <inkml:channel name="Y" type="integer" min="-2.14748E9" max="2.14748E9" units="cm"/>
+          <inkml:channel name="F" type="integer" max="32767" units="dev"/>
+        </inkml:traceFormat>
+        <inkml:channelProperties>
+          <inkml:channelProperty channel="X" name="resolution" value="1000" units="1/cm"/>
+          <inkml:channelProperty channel="Y" name="resolution" value="1000" units="1/cm"/>
+          <inkml:channelProperty channel="F" name="resolution" value="0" units="1/dev"/>
+        </inkml:channelProperties>
+      </inkml:inkSource>
+      <inkml:timestamp xml:id="ts0" timeString="2026-09-16T09:52:43.421"/>
+    </inkml:context>
+    <inkml:brush xml:id="br0">
+      <inkml:brushProperty name="width" value="0.035" units="cm"/>
+      <inkml:brushProperty name="height" value="0.035" units="cm"/>
+      <inkml:brushProperty name="color" value="#FF0000"/>
+    </inkml:brush>
+  </inkml:definitions>
+  <inkml:trace contextRef="#ctx0" brushRef="#br0">0 0 24518,'0'798'0,"3417"-798"0,-3417-798 0,-3417 798 0</inkml:trace>
+</inkml:ink>
+</file>
+
+<file path=ppt/ink/ink14.xml><?xml version="1.0" encoding="utf-8"?>
+<inkml:ink xmlns:inkml="http://www.w3.org/2003/InkML">
+  <inkml:definitions>
+    <inkml:context xml:id="ctx0">
+      <inkml:inkSource xml:id="inkSrc0">
+        <inkml:traceFormat>
+          <inkml:channel name="X" type="integer" min="-2.14748E9" max="2.14748E9" units="cm"/>
+          <inkml:channel name="Y" type="integer" min="-2.14748E9" max="2.14748E9" units="cm"/>
+          <inkml:channel name="F" type="integer" max="32767" units="dev"/>
+        </inkml:traceFormat>
+        <inkml:channelProperties>
+          <inkml:channelProperty channel="X" name="resolution" value="1000" units="1/cm"/>
+          <inkml:channelProperty channel="Y" name="resolution" value="1000" units="1/cm"/>
+          <inkml:channelProperty channel="F" name="resolution" value="0" units="1/dev"/>
+        </inkml:channelProperties>
+      </inkml:inkSource>
+      <inkml:timestamp xml:id="ts0" timeString="2026-09-16T09:52:57.530"/>
+    </inkml:context>
+    <inkml:brush xml:id="br0">
+      <inkml:brushProperty name="width" value="0.035" units="cm"/>
+      <inkml:brushProperty name="height" value="0.035" units="cm"/>
+      <inkml:brushProperty name="color" value="#FF0000"/>
+    </inkml:brush>
+  </inkml:definitions>
+  <inkml:trace contextRef="#ctx0" brushRef="#br0">211 71 24575,'-8'0'0,"0"-1"0,0 2 0,0-1 0,0 1 0,0 1 0,0-1 0,1 1 0,-1 0 0,1 1 0,-1 0 0,1 0 0,0 1 0,0 0 0,0 0 0,0 1 0,1-1 0,0 1 0,0 1 0,0-1 0,0 1 0,1 0 0,0 1 0,1-1 0,-1 1 0,1 0 0,0 0 0,-4 12 0,3-7 0,0 1 0,2 0 0,-1 0 0,1 0 0,1 0 0,1 0 0,0 1 0,0-1 0,1 1 0,4 22 0,-2-26 0,0-1 0,1 1 0,0 0 0,0 0 0,1-1 0,1 0 0,0 0 0,0 0 0,0-1 0,1 1 0,1-1 0,-1-1 0,1 1 0,12 9 0,129 90 0,-96-72 0,72 62 0,-113-88 0,0-1 0,0 0 0,0-1 0,1 0 0,0 0 0,0-2 0,1 1 0,0-2 0,0 0 0,0 0 0,0-1 0,20 2 0,15-2 0,-1-1 0,61-7 0,-14 1 0,609 3 0,-668-1 0,-1-2 0,56-12 0,-53 8 0,73-5 0,-17 12 0,-51 2 0,0-2 0,-1-1 0,1-2 0,-1-2 0,68-19 0,-68 13 0,0 1 0,1 2 0,0 3 0,55-3 0,175 9 0,-112 4 0,-42-2 0,-48 1 0,-1-3 0,91-13 0,-127 8 0,0-1 0,-1-3 0,0 0 0,-1-2 0,0-1 0,56-32 0,-82 42 0,-1-1 0,0 0 0,0 0 0,0-1 0,-1 1 0,1-1 0,-1 0 0,0 0 0,0 0 0,0 0 0,-1 0 0,1-1 0,-1 1 0,0-1 0,0 0 0,-1 1 0,1-1 0,0-9 0,-1 7 0,-1-1 0,-1 0 0,1 0 0,-1 1 0,-1-1 0,1 1 0,-1-1 0,-1 1 0,1-1 0,-1 1 0,-5-7 0,-7-12 0,-1 1 0,-1 1 0,-2 1 0,0 1 0,-29-27 0,16 24 0,0 1 0,-2 1 0,-1 2 0,0 2 0,-74-30 0,106 48 0,-21-8 0,-1 1 0,0 0 0,0 2 0,-1 1 0,-50-3 0,-136 9 0,99 2 0,-30 0 0,-221-6 0,255-12 0,85 10 0,0 1 0,0 1 0,0 1 0,0 1 0,0 1 0,-36 5 0,-21 8 0,-132 4 0,-84-18 0,106-2 0,-744 3 0,920 0 20,0 0 0,0 1 0,0 1 0,0 1 0,-19 5 0,28-6-113,0 0 0,0 1 1,0-1-1,1 1 0,0 1 0,-1-1 0,1 1 0,0 0 1,1 0-1,-1 0 0,1 1 0,0-1 0,0 1 1,0 0-1,-3 7 0,-8 18-6733</inkml:trace>
+</inkml:ink>
+</file>
+
+<file path=ppt/ink/ink15.xml><?xml version="1.0" encoding="utf-8"?>
+<inkml:ink xmlns:inkml="http://www.w3.org/2003/InkML">
+  <inkml:definitions>
+    <inkml:context xml:id="ctx0">
+      <inkml:inkSource xml:id="inkSrc0">
+        <inkml:traceFormat>
+          <inkml:channel name="X" type="integer" min="-2.14748E9" max="2.14748E9" units="cm"/>
+          <inkml:channel name="Y" type="integer" min="-2.14748E9" max="2.14748E9" units="cm"/>
+          <inkml:channel name="F" type="integer" max="32767" units="dev"/>
+        </inkml:traceFormat>
+        <inkml:channelProperties>
+          <inkml:channelProperty channel="X" name="resolution" value="1000" units="1/cm"/>
+          <inkml:channelProperty channel="Y" name="resolution" value="1000" units="1/cm"/>
+          <inkml:channelProperty channel="F" name="resolution" value="0" units="1/dev"/>
+        </inkml:channelProperties>
+      </inkml:inkSource>
+      <inkml:timestamp xml:id="ts0" timeString="2026-09-16T09:55:52.167"/>
+    </inkml:context>
+    <inkml:brush xml:id="br0">
+      <inkml:brushProperty name="width" value="0.035" units="cm"/>
+      <inkml:brushProperty name="height" value="0.035" units="cm"/>
+      <inkml:brushProperty name="color" value="#FF0000"/>
+    </inkml:brush>
+  </inkml:definitions>
+  <inkml:trace contextRef="#ctx0" brushRef="#br0">113 702 24575,'285'0'0,"-260"-2"0,-1-1 0,1-1 0,-1-1 0,0-1 0,36-15 0,-31 11 0,1 1 0,-1 1 0,32-4 0,41 5 0,131 9 0,-76 1 0,622-3 0,-740 2 0,1 2 0,50 11 0,-47-6 0,72 4 0,57-15 0,66 4 0,-111 17 0,-83-11 0,72 5 0,-100-12 0,1-1 0,-1 0 0,0-1 0,1-1 0,16-4 0,-28 4 0,1 0 0,-1 0 0,0 0 0,0-1 0,0 0 0,0 0 0,-1 0 0,1-1 0,-1 1 0,0-1 0,0 0 0,0 0 0,0-1 0,-1 1 0,1-1 0,-1 0 0,5-9 0,1-7 0,-1 1 0,-1-1 0,0-1 0,-2 1 0,0-1 0,2-34 0,-5 12 0,-1-1 0,-7-56 0,5 94 0,0-1 0,0 1 0,-1 0 0,0-1 0,0 1 0,-1 0 0,0 1 0,0-1 0,0 0 0,-1 1 0,0 0 0,0-1 0,-1 2 0,0-1 0,0 0 0,0 1 0,0 0 0,-1 0 0,0 1 0,0 0 0,0 0 0,-1 0 0,0 1 0,1 0 0,-1 0 0,0 0 0,0 1 0,-14-3 0,-16-1 0,-1 2 0,1 1 0,-1 2 0,-58 5 0,33-1 0,8-1 0,-1-2 0,0-3 0,1-2 0,0-3 0,-78-20 0,86 15 0,-1 3 0,-1 2 0,-79-4 0,-151 13 0,110 2 0,-667-3 0,805 2 0,1 1 0,-53 12 0,-19 3 0,-33 3 0,84-11 0,-91 5 0,84-17 0,42 0 0,1 1 0,-1 1 0,1 1 0,-1 0 0,1 1 0,-30 7 0,41-7 0,0 0 0,1 0 0,-1 0 0,1 1 0,0 0 0,0 0 0,-1 0 0,2 0 0,-1 0 0,0 0 0,1 1 0,-1-1 0,1 1 0,0 0 0,0 0 0,1 0 0,-1-1 0,1 2 0,0-1 0,0 0 0,0 0 0,0 8 0,-1 12 0,1 0 0,4 46 0,-1-39 0,-2-6 0,-2 0 0,0-1 0,-7 25 0,-3 38 0,12-83 0,0 0 0,0 0 0,0 0 0,1 0 0,-1 0 0,1 0 0,0-1 0,0 1 0,0 0 0,1 0 0,-1-1 0,1 1 0,0 0 0,0-1 0,0 0 0,5 6 0,-2-4 0,-1-1 0,1 0 0,0 0 0,1-1 0,-1 1 0,1-1 0,-1 0 0,1-1 0,10 4 0,7 0 0,0-1 0,0-2 0,0 0 0,39-1 0,27-4-98,-43-1 207,77 7 1,-111-3-234,-1 1 0,1 0 0,-1 0 1,1 1-1,-1 1 0,0 0 0,0 1 0,-1 0 0,1 0 1,-1 1-1,15 11 0,-3 5-6702</inkml:trace>
+</inkml:ink>
+</file>
+
+<file path=ppt/ink/ink16.xml><?xml version="1.0" encoding="utf-8"?>
+<inkml:ink xmlns:inkml="http://www.w3.org/2003/InkML">
+  <inkml:definitions>
+    <inkml:context xml:id="ctx0">
+      <inkml:inkSource xml:id="inkSrc0">
+        <inkml:traceFormat>
+          <inkml:channel name="X" type="integer" min="-2.14748E9" max="2.14748E9" units="cm"/>
+          <inkml:channel name="Y" type="integer" min="-2.14748E9" max="2.14748E9" units="cm"/>
+          <inkml:channel name="F" type="integer" max="32767" units="dev"/>
+        </inkml:traceFormat>
+        <inkml:channelProperties>
+          <inkml:channelProperty channel="X" name="resolution" value="1000" units="1/cm"/>
+          <inkml:channelProperty channel="Y" name="resolution" value="1000" units="1/cm"/>
+          <inkml:channelProperty channel="F" name="resolution" value="0" units="1/dev"/>
+        </inkml:channelProperties>
+      </inkml:inkSource>
+      <inkml:timestamp xml:id="ts0" timeString="2026-09-17T05:20:15.537"/>
+    </inkml:context>
+    <inkml:brush xml:id="br0">
+      <inkml:brushProperty name="width" value="0.035" units="cm"/>
+      <inkml:brushProperty name="height" value="0.035" units="cm"/>
+      <inkml:brushProperty name="color" value="#FF0000"/>
+    </inkml:brush>
+  </inkml:definitions>
+  <inkml:trace contextRef="#ctx0" brushRef="#br0">252 88 24575,'-5'0'0,"0"1"0,0 0 0,0 0 0,0 1 0,0-1 0,0 1 0,1 0 0,-1 0 0,1 1 0,-1-1 0,1 1 0,0 0 0,0 0 0,0 0 0,0 1 0,1-1 0,0 1 0,-1 0 0,1 0 0,-3 7 0,-8 10 0,2 1 0,-17 44 0,20-47 0,-56 151 0,57-143 0,1 1 0,2-1 0,0 1 0,0 43 0,4-6 0,10 80 0,-6-119 0,2-1 0,0 1 0,2-1 0,1 0 0,1-1 0,12 24 0,-3-12 0,0 1 0,2-1 0,30 42 0,-32-52 0,1-1 0,1-1 0,1-1 0,1-1 0,1-1 0,1-1 0,38 25 0,-40-31 0,1-1 0,0-1 0,1-1 0,0-1 0,0-1 0,1-1 0,0-2 0,33 5 0,12 0 0,131 36 0,-196-46 0,45 10 0,0-3 0,0-2 0,62 0 0,-48-4 0,76 14 0,114 40 0,-145-29 0,1-4 0,127 9 0,-203-30 0,145 14 0,53 4 0,1 0 0,98 30 0,-214-38 0,0-5 0,128-9 0,-84-1 0,-92 3 0,74-11 0,-112 6 0,-1-1 0,1-1 0,-2-2 0,52-22 0,-7 0 0,142-39 0,-188 62 0,0-2 0,-1-1 0,0-1 0,49-30 0,-29 10 0,71-63 0,-36 29 0,-44 37 0,60-59 0,-88 77 0,-1 1 0,0-1 0,-1 0 0,-1-1 0,1 0 0,-2 0 0,0 0 0,0-1 0,-1 0 0,5-22 0,-4-14 0,-2 0 0,-2 1 0,-3-1 0,-10-78 0,8 93 0,-1 3 0,-1-1 0,-2 1 0,-2 0 0,0 1 0,-2 0 0,-1 0 0,-2 1 0,-1 1 0,-1 0 0,-1 2 0,-1-1 0,-2 2 0,0 1 0,-26-24 0,26 28 0,-1 1 0,-1 1 0,-1 2 0,0 0 0,-1 1 0,-1 1 0,0 1 0,-1 1 0,0 2 0,-35-10 0,-43-10 0,-1 5 0,-2 4 0,0 5 0,-182-4 0,253 21 0,-19 1 0,-1-3 0,1-1 0,-1-4 0,-104-23 0,102 15 0,0 2 0,0 2 0,-83-2 0,-181 13 0,124 3 0,-478-4 0,652 1 0,0 2 0,0 0 0,-34 10 0,30-6 0,-56 7 0,-384-11 0,241-6 0,82 1 0,-156 6 0,283-2 0,0 2 0,0 0 0,0 1 0,1 1 0,-27 12 0,25-9 0,1-2 0,-1 0 0,-1-1 0,-23 3 0,5-5-1365,3-2-5461</inkml:trace>
+</inkml:ink>
+</file>
+
+<file path=ppt/ink/ink17.xml><?xml version="1.0" encoding="utf-8"?>
+<inkml:ink xmlns:inkml="http://www.w3.org/2003/InkML">
+  <inkml:definitions>
+    <inkml:context xml:id="ctx0">
+      <inkml:inkSource xml:id="inkSrc0">
+        <inkml:traceFormat>
+          <inkml:channel name="X" type="integer" min="-2.14748E9" max="2.14748E9" units="cm"/>
+          <inkml:channel name="Y" type="integer" min="-2.14748E9" max="2.14748E9" units="cm"/>
+          <inkml:channel name="F" type="integer" max="32767" units="dev"/>
+        </inkml:traceFormat>
+        <inkml:channelProperties>
+          <inkml:channelProperty channel="X" name="resolution" value="1000" units="1/cm"/>
+          <inkml:channelProperty channel="Y" name="resolution" value="1000" units="1/cm"/>
+          <inkml:channelProperty channel="F" name="resolution" value="0" units="1/dev"/>
+        </inkml:channelProperties>
+      </inkml:inkSource>
+      <inkml:timestamp xml:id="ts0" timeString="2026-09-17T05:21:28.094"/>
+    </inkml:context>
+    <inkml:brush xml:id="br0">
+      <inkml:brushProperty name="width" value="0.035" units="cm"/>
+      <inkml:brushProperty name="height" value="0.035" units="cm"/>
+      <inkml:brushProperty name="color" value="#FF0000"/>
+    </inkml:brush>
+  </inkml:definitions>
+  <inkml:trace contextRef="#ctx0" brushRef="#br0">0 420 24575,'1'3'0,"0"0"0,1 0 0,-1 0 0,0 0 0,1 0 0,0 0 0,0-1 0,0 1 0,0 0 0,0-1 0,0 1 0,1-1 0,2 2 0,10 12 0,35 45 0,86 81 0,-133-138 0,0-1 0,1 0 0,-1 0 0,1 0 0,0-1 0,0 1 0,0-1 0,0 0 0,0 0 0,0 0 0,1 0 0,-1-1 0,1 0 0,-1 0 0,1 0 0,0-1 0,-1 1 0,1-1 0,0 0 0,8-1 0,-6-1 0,-1-1 0,1 1 0,-1-1 0,0 0 0,0 0 0,0-1 0,-1 1 0,1-1 0,-1-1 0,0 1 0,0-1 0,-1 0 0,1 0 0,4-6 0,9-17 0,0-1 0,-2 0 0,17-42 0,11-20 0,2 9-455,4 2 0,106-130 0,-127 179-6371</inkml:trace>
+</inkml:ink>
+</file>
+
+<file path=ppt/ink/ink18.xml><?xml version="1.0" encoding="utf-8"?>
+<inkml:ink xmlns:inkml="http://www.w3.org/2003/InkML">
+  <inkml:definitions>
+    <inkml:context xml:id="ctx0">
+      <inkml:inkSource xml:id="inkSrc0">
+        <inkml:traceFormat>
+          <inkml:channel name="X" type="integer" min="-2.14748E9" max="2.14748E9" units="cm"/>
+          <inkml:channel name="Y" type="integer" min="-2.14748E9" max="2.14748E9" units="cm"/>
+          <inkml:channel name="F" type="integer" max="32767" units="dev"/>
+        </inkml:traceFormat>
+        <inkml:channelProperties>
+          <inkml:channelProperty channel="X" name="resolution" value="1000" units="1/cm"/>
+          <inkml:channelProperty channel="Y" name="resolution" value="1000" units="1/cm"/>
+          <inkml:channelProperty channel="F" name="resolution" value="0" units="1/dev"/>
+        </inkml:channelProperties>
+      </inkml:inkSource>
+      <inkml:timestamp xml:id="ts0" timeString="2026-09-17T05:23:16.940"/>
+    </inkml:context>
+    <inkml:brush xml:id="br0">
+      <inkml:brushProperty name="width" value="0.035" units="cm"/>
+      <inkml:brushProperty name="height" value="0.035" units="cm"/>
+      <inkml:brushProperty name="color" value="#FF0000"/>
+    </inkml:brush>
+  </inkml:definitions>
+  <inkml:trace contextRef="#ctx0" brushRef="#br0">1 42 24575,'573'0'0,"-540"-1"0,-1-3 0,57-12 0,-61 10 0,0 0 0,0 2 0,1 2 0,32 0 0,-43 5 0,0 0 0,-1 2 0,1 0 0,-1 1 0,-1 0 0,1 2 0,27 16 0,-18-10 0,46 18 0,-38-22-1365,-3-4-5461</inkml:trace>
+</inkml:ink>
+</file>
+
+<file path=ppt/ink/ink19.xml><?xml version="1.0" encoding="utf-8"?>
+<inkml:ink xmlns:inkml="http://www.w3.org/2003/InkML">
+  <inkml:definitions>
+    <inkml:context xml:id="ctx0">
+      <inkml:inkSource xml:id="inkSrc0">
+        <inkml:traceFormat>
+          <inkml:channel name="X" type="integer" min="-2.14748E9" max="2.14748E9" units="cm"/>
+          <inkml:channel name="Y" type="integer" min="-2.14748E9" max="2.14748E9" units="cm"/>
+          <inkml:channel name="F" type="integer" max="32767" units="dev"/>
+        </inkml:traceFormat>
+        <inkml:channelProperties>
+          <inkml:channelProperty channel="X" name="resolution" value="1000" units="1/cm"/>
+          <inkml:channelProperty channel="Y" name="resolution" value="1000" units="1/cm"/>
+          <inkml:channelProperty channel="F" name="resolution" value="0" units="1/dev"/>
+        </inkml:channelProperties>
+      </inkml:inkSource>
+      <inkml:timestamp xml:id="ts0" timeString="2026-09-17T05:23:19.572"/>
+    </inkml:context>
+    <inkml:brush xml:id="br0">
+      <inkml:brushProperty name="width" value="0.035" units="cm"/>
+      <inkml:brushProperty name="height" value="0.035" units="cm"/>
+      <inkml:brushProperty name="color" value="#FF0000"/>
+    </inkml:brush>
+  </inkml:definitions>
+  <inkml:trace contextRef="#ctx0" brushRef="#br0">1 1 24575,'1436'0'-1365,"-1401"0"-5461</inkml:trace>
+</inkml:ink>
+</file>
+
+<file path=ppt/ink/ink2.xml><?xml version="1.0" encoding="utf-8"?>
+<inkml:ink xmlns:inkml="http://www.w3.org/2003/InkML">
+  <inkml:definitions>
+    <inkml:context xml:id="ctx0">
+      <inkml:inkSource xml:id="inkSrc0">
+        <inkml:traceFormat>
+          <inkml:channel name="X" type="integer" min="-2.14748E9" max="2.14748E9" units="cm"/>
+          <inkml:channel name="Y" type="integer" min="-2.14748E9" max="2.14748E9" units="cm"/>
+          <inkml:channel name="F" type="integer" max="32767" units="dev"/>
+        </inkml:traceFormat>
+        <inkml:channelProperties>
+          <inkml:channelProperty channel="X" name="resolution" value="1000" units="1/cm"/>
+          <inkml:channelProperty channel="Y" name="resolution" value="1000" units="1/cm"/>
+          <inkml:channelProperty channel="F" name="resolution" value="0" units="1/dev"/>
+        </inkml:channelProperties>
+      </inkml:inkSource>
+      <inkml:timestamp xml:id="ts0" timeString="2026-09-15T11:06:46.261"/>
+    </inkml:context>
+    <inkml:brush xml:id="br0">
+      <inkml:brushProperty name="width" value="0.035" units="cm"/>
+      <inkml:brushProperty name="height" value="0.035" units="cm"/>
+      <inkml:brushProperty name="color" value="#FF0000"/>
+    </inkml:brush>
+  </inkml:definitions>
+  <inkml:trace contextRef="#ctx0" brushRef="#br0">0 81 24462,'5040'-81'0</inkml:trace>
+</inkml:ink>
+</file>
+
+<file path=ppt/ink/ink3.xml><?xml version="1.0" encoding="utf-8"?>
+<inkml:ink xmlns:inkml="http://www.w3.org/2003/InkML">
+  <inkml:definitions>
+    <inkml:context xml:id="ctx0">
+      <inkml:inkSource xml:id="inkSrc0">
+        <inkml:traceFormat>
+          <inkml:channel name="X" type="integer" min="-2.14748E9" max="2.14748E9" units="cm"/>
+          <inkml:channel name="Y" type="integer" min="-2.14748E9" max="2.14748E9" units="cm"/>
+          <inkml:channel name="F" type="integer" max="32767" units="dev"/>
+        </inkml:traceFormat>
+        <inkml:channelProperties>
+          <inkml:channelProperty channel="X" name="resolution" value="1000" units="1/cm"/>
+          <inkml:channelProperty channel="Y" name="resolution" value="1000" units="1/cm"/>
+          <inkml:channelProperty channel="F" name="resolution" value="0" units="1/dev"/>
+        </inkml:channelProperties>
+      </inkml:inkSource>
+      <inkml:timestamp xml:id="ts0" timeString="2026-09-15T11:06:49.444"/>
+    </inkml:context>
+    <inkml:brush xml:id="br0">
+      <inkml:brushProperty name="width" value="0.035" units="cm"/>
+      <inkml:brushProperty name="height" value="0.035" units="cm"/>
+      <inkml:brushProperty name="color" value="#FF0000"/>
+    </inkml:brush>
+  </inkml:definitions>
+  <inkml:trace contextRef="#ctx0" brushRef="#br0">1 432 24575,'7'0'0,"2"-7"0,-1-9 0,-1-10 0,-2-6 0,-2-5 0,-1-4 0,-1-1 0,-1-1 0,-1 0 0,1 1 0,-7 0 0,-3 7 0,2 10-8191</inkml:trace>
+</inkml:ink>
+</file>
+
+<file path=ppt/ink/ink4.xml><?xml version="1.0" encoding="utf-8"?>
+<inkml:ink xmlns:inkml="http://www.w3.org/2003/InkML">
+  <inkml:definitions>
+    <inkml:context xml:id="ctx0">
+      <inkml:inkSource xml:id="inkSrc0">
+        <inkml:traceFormat>
+          <inkml:channel name="X" type="integer" min="-2.14748E9" max="2.14748E9" units="cm"/>
+          <inkml:channel name="Y" type="integer" min="-2.14748E9" max="2.14748E9" units="cm"/>
+          <inkml:channel name="F" type="integer" max="32767" units="dev"/>
+        </inkml:traceFormat>
+        <inkml:channelProperties>
+          <inkml:channelProperty channel="X" name="resolution" value="1000" units="1/cm"/>
+          <inkml:channelProperty channel="Y" name="resolution" value="1000" units="1/cm"/>
+          <inkml:channelProperty channel="F" name="resolution" value="0" units="1/dev"/>
+        </inkml:channelProperties>
+      </inkml:inkSource>
+      <inkml:timestamp xml:id="ts0" timeString="2026-09-15T11:06:54.583"/>
+    </inkml:context>
+    <inkml:brush xml:id="br0">
+      <inkml:brushProperty name="width" value="0.035" units="cm"/>
+      <inkml:brushProperty name="height" value="0.035" units="cm"/>
+      <inkml:brushProperty name="color" value="#FF0000"/>
+    </inkml:brush>
+  </inkml:definitions>
+  <inkml:trace contextRef="#ctx0" brushRef="#br0">5081 0 24318,'-5081'0'0</inkml:trace>
+</inkml:ink>
+</file>
+
+<file path=ppt/ink/ink5.xml><?xml version="1.0" encoding="utf-8"?>
+<inkml:ink xmlns:inkml="http://www.w3.org/2003/InkML">
+  <inkml:definitions>
+    <inkml:context xml:id="ctx0">
+      <inkml:inkSource xml:id="inkSrc0">
+        <inkml:traceFormat>
+          <inkml:channel name="X" type="integer" min="-2.14748E9" max="2.14748E9" units="cm"/>
+          <inkml:channel name="Y" type="integer" min="-2.14748E9" max="2.14748E9" units="cm"/>
+          <inkml:channel name="F" type="integer" max="32767" units="dev"/>
+        </inkml:traceFormat>
+        <inkml:channelProperties>
+          <inkml:channelProperty channel="X" name="resolution" value="1000" units="1/cm"/>
+          <inkml:channelProperty channel="Y" name="resolution" value="1000" units="1/cm"/>
+          <inkml:channelProperty channel="F" name="resolution" value="0" units="1/dev"/>
+        </inkml:channelProperties>
+      </inkml:inkSource>
+      <inkml:timestamp xml:id="ts0" timeString="2026-09-15T11:06:58.358"/>
+    </inkml:context>
+    <inkml:brush xml:id="br0">
+      <inkml:brushProperty name="width" value="0.035" units="cm"/>
+      <inkml:brushProperty name="height" value="0.035" units="cm"/>
+      <inkml:brushProperty name="color" value="#FF0000"/>
+    </inkml:brush>
+  </inkml:definitions>
+  <inkml:trace contextRef="#ctx0" brushRef="#br0">44 1 24575,'-7'0'0,"-2"13"0,0 13 0,1 8 0,3 5 0,2 3 0,1 2 0,2 0 0,0-1 0,7 0 0,3-1 0,-1 0 0,-1-1 0,-3 0 0,-1 0 0,4 0 0,2-7-8191</inkml:trace>
+</inkml:ink>
+</file>
+
+<file path=ppt/ink/ink6.xml><?xml version="1.0" encoding="utf-8"?>
+<inkml:ink xmlns:inkml="http://www.w3.org/2003/InkML">
+  <inkml:definitions>
+    <inkml:context xml:id="ctx0">
+      <inkml:inkSource xml:id="inkSrc0">
+        <inkml:traceFormat>
+          <inkml:channel name="X" type="integer" min="-2.14748E9" max="2.14748E9" units="cm"/>
+          <inkml:channel name="Y" type="integer" min="-2.14748E9" max="2.14748E9" units="cm"/>
+          <inkml:channel name="F" type="integer" max="32767" units="dev"/>
+        </inkml:traceFormat>
+        <inkml:channelProperties>
+          <inkml:channelProperty channel="X" name="resolution" value="1000" units="1/cm"/>
+          <inkml:channelProperty channel="Y" name="resolution" value="1000" units="1/cm"/>
+          <inkml:channelProperty channel="F" name="resolution" value="0" units="1/dev"/>
+        </inkml:channelProperties>
+      </inkml:inkSource>
+      <inkml:timestamp xml:id="ts0" timeString="2026-09-15T11:07:58.836"/>
+    </inkml:context>
+    <inkml:brush xml:id="br0">
+      <inkml:brushProperty name="width" value="0.035" units="cm"/>
+      <inkml:brushProperty name="height" value="0.035" units="cm"/>
+      <inkml:brushProperty name="color" value="#FF0000"/>
+    </inkml:brush>
+  </inkml:definitions>
+  <inkml:trace contextRef="#ctx0" brushRef="#br0">0 0 23209,'4836'0'0</inkml:trace>
+</inkml:ink>
+</file>
+
+<file path=ppt/ink/ink7.xml><?xml version="1.0" encoding="utf-8"?>
+<inkml:ink xmlns:inkml="http://www.w3.org/2003/InkML">
+  <inkml:definitions>
+    <inkml:context xml:id="ctx0">
+      <inkml:inkSource xml:id="inkSrc0">
+        <inkml:traceFormat>
+          <inkml:channel name="X" type="integer" min="-2.14748E9" max="2.14748E9" units="cm"/>
+          <inkml:channel name="Y" type="integer" min="-2.14748E9" max="2.14748E9" units="cm"/>
+          <inkml:channel name="F" type="integer" max="32767" units="dev"/>
+        </inkml:traceFormat>
+        <inkml:channelProperties>
+          <inkml:channelProperty channel="X" name="resolution" value="1000" units="1/cm"/>
+          <inkml:channelProperty channel="Y" name="resolution" value="1000" units="1/cm"/>
+          <inkml:channelProperty channel="F" name="resolution" value="0" units="1/dev"/>
+        </inkml:channelProperties>
+      </inkml:inkSource>
+      <inkml:timestamp xml:id="ts0" timeString="2026-09-15T11:08:03.870"/>
+    </inkml:context>
+    <inkml:brush xml:id="br0">
+      <inkml:brushProperty name="width" value="0.035" units="cm"/>
+      <inkml:brushProperty name="height" value="0.035" units="cm"/>
+      <inkml:brushProperty name="color" value="#FF0000"/>
+    </inkml:brush>
+  </inkml:definitions>
+  <inkml:trace contextRef="#ctx0" brushRef="#br0">0 407 24575,'0'-7'0,"0"-10"0,0-8 0,0-7 0,0-6 0,0-2 0,0-2 0,0-1 0,0 0 0,0 1 0,0 0 0,0 7-8191</inkml:trace>
+</inkml:ink>
+</file>
+
+<file path=ppt/ink/ink8.xml><?xml version="1.0" encoding="utf-8"?>
+<inkml:ink xmlns:inkml="http://www.w3.org/2003/InkML">
+  <inkml:definitions>
+    <inkml:context xml:id="ctx0">
+      <inkml:inkSource xml:id="inkSrc0">
+        <inkml:traceFormat>
+          <inkml:channel name="X" type="integer" min="-2.14748E9" max="2.14748E9" units="cm"/>
+          <inkml:channel name="Y" type="integer" min="-2.14748E9" max="2.14748E9" units="cm"/>
+          <inkml:channel name="F" type="integer" max="32767" units="dev"/>
+        </inkml:traceFormat>
+        <inkml:channelProperties>
+          <inkml:channelProperty channel="X" name="resolution" value="1000" units="1/cm"/>
+          <inkml:channelProperty channel="Y" name="resolution" value="1000" units="1/cm"/>
+          <inkml:channelProperty channel="F" name="resolution" value="0" units="1/dev"/>
+        </inkml:channelProperties>
+      </inkml:inkSource>
+      <inkml:timestamp xml:id="ts0" timeString="2026-09-15T11:08:08.440"/>
+    </inkml:context>
+    <inkml:brush xml:id="br0">
+      <inkml:brushProperty name="width" value="0.035" units="cm"/>
+      <inkml:brushProperty name="height" value="0.035" units="cm"/>
+      <inkml:brushProperty name="color" value="#FF0000"/>
+    </inkml:brush>
+  </inkml:definitions>
+  <inkml:trace contextRef="#ctx0" brushRef="#br0">4958 40 24432,'-4958'-40'0</inkml:trace>
+</inkml:ink>
+</file>
+
+<file path=ppt/ink/ink9.xml><?xml version="1.0" encoding="utf-8"?>
+<inkml:ink xmlns:inkml="http://www.w3.org/2003/InkML">
+  <inkml:definitions>
+    <inkml:context xml:id="ctx0">
+      <inkml:inkSource xml:id="inkSrc0">
+        <inkml:traceFormat>
+          <inkml:channel name="X" type="integer" min="-2.14748E9" max="2.14748E9" units="cm"/>
+          <inkml:channel name="Y" type="integer" min="-2.14748E9" max="2.14748E9" units="cm"/>
+          <inkml:channel name="F" type="integer" max="32767" units="dev"/>
+        </inkml:traceFormat>
+        <inkml:channelProperties>
+          <inkml:channelProperty channel="X" name="resolution" value="1000" units="1/cm"/>
+          <inkml:channelProperty channel="Y" name="resolution" value="1000" units="1/cm"/>
+          <inkml:channelProperty channel="F" name="resolution" value="0" units="1/dev"/>
+        </inkml:channelProperties>
+      </inkml:inkSource>
+      <inkml:timestamp xml:id="ts0" timeString="2026-09-15T11:08:11.465"/>
+    </inkml:context>
+    <inkml:brush xml:id="br0">
+      <inkml:brushProperty name="width" value="0.035" units="cm"/>
+      <inkml:brushProperty name="height" value="0.035" units="cm"/>
+      <inkml:brushProperty name="color" value="#FF0000"/>
+    </inkml:brush>
+  </inkml:definitions>
+  <inkml:trace contextRef="#ctx0" brushRef="#br0">0 0 24575,'0'7'0,"0"9"0,0 9 0,0 7 0,0 5 0,0 3 0,0 2 0,0 1 0,0 0 0,0-1 0,0 1 0,0-2 0,0 1 0,0-1 0,8-7 0,1-2 0,7-1 0,0-4-8191</inkml:trace>
+</inkml:ink>
+</file>
+
+<file path=ppt/notesMasters/notesMaster1.xml><?xml version="1.0" encoding="utf-8"?>
+<p:notesMaster xmlns:a="http://schemas.openxmlformats.org/drawingml/2006/main" xmlns:r="http://schemas.openxmlformats.org/officeDocument/2006/relationships" xmlns:p="http://schemas.openxmlformats.org/presentationml/2006/main">
+  <p:cSld>
+    <p:bg>
+      <p:bgRef idx="1001">
+        <a:schemeClr val="bg1"/>
+      </p:bgRef>
+    </p:bg>
+    <p:spTree>
+      <p:nvGrpSpPr>
+        <p:cNvPr id="1" name=""/>
+        <p:cNvGrpSpPr/>
+        <p:nvPr/>
+      </p:nvGrpSpPr>
+      <p:grpSpPr>
+        <a:xfrm>
+          <a:off x="0" y="0"/>
+          <a:ext cx="0" cy="0"/>
+          <a:chOff x="0" y="0"/>
+          <a:chExt cx="0" cy="0"/>
+        </a:xfrm>
+      </p:grpSpPr>
+      <p:sp>
+        <p:nvSpPr>
+          <p:cNvPr id="2" name="Header Placeholder 1"/>
+          <p:cNvSpPr>
+            <a:spLocks noGrp="1"/>
+          </p:cNvSpPr>
+          <p:nvPr>
+            <p:ph type="hdr" sz="quarter"/>
+          </p:nvPr>
+        </p:nvSpPr>
+        <p:spPr>
+          <a:xfrm>
+            <a:off x="0" y="0"/>
+            <a:ext cx="2971800" cy="458788"/>
+          </a:xfrm>
+          <a:prstGeom prst="rect">
+            <a:avLst/>
+          </a:prstGeom>
+        </p:spPr>
+        <p:txBody>
+          <a:bodyPr vert="horz" lIns="91440" tIns="45720" rIns="91440" bIns="45720" rtlCol="0"/>
+          <a:lstStyle>
+            <a:lvl1pPr algn="l">
+              <a:defRPr sz="1200"/>
+            </a:lvl1pPr>
+          </a:lstStyle>
+          <a:p>
+            <a:endParaRPr lang="en-NZ"/>
+          </a:p>
+        </p:txBody>
+      </p:sp>
+      <p:sp>
+        <p:nvSpPr>
+          <p:cNvPr id="3" name="Date Placeholder 2"/>
+          <p:cNvSpPr>
+            <a:spLocks noGrp="1"/>
+          </p:cNvSpPr>
+          <p:nvPr>
+            <p:ph type="dt" idx="1"/>
+          </p:nvPr>
+        </p:nvSpPr>
+        <p:spPr>
+          <a:xfrm>
+            <a:off x="3884613" y="0"/>
+            <a:ext cx="2971800" cy="458788"/>
+          </a:xfrm>
+          <a:prstGeom prst="rect">
+            <a:avLst/>
+          </a:prstGeom>
+        </p:spPr>
+        <p:txBody>
+          <a:bodyPr vert="horz" lIns="91440" tIns="45720" rIns="91440" bIns="45720" rtlCol="0"/>
+          <a:lstStyle>
+            <a:lvl1pPr algn="r">
+              <a:defRPr sz="1200"/>
+            </a:lvl1pPr>
+          </a:lstStyle>
+          <a:p>
+            <a:fld id="{480111A6-83EF-49C5-A3C9-60D202FFE003}" type="datetimeFigureOut">
+              <a:rPr lang="en-NZ" smtClean="0"/>
+              <a:t>18/09/2026</a:t>
+            </a:fld>
+            <a:endParaRPr lang="en-NZ"/>
+          </a:p>
+        </p:txBody>
+      </p:sp>
+      <p:sp>
+        <p:nvSpPr>
+          <p:cNvPr id="4" name="Slide Image Placeholder 3"/>
+          <p:cNvSpPr>
+            <a:spLocks noGrp="1" noRot="1" noChangeAspect="1"/>
+          </p:cNvSpPr>
+          <p:nvPr>
+            <p:ph type="sldImg" idx="2"/>
+          </p:nvPr>
+        </p:nvSpPr>
+        <p:spPr>
+          <a:xfrm>
+            <a:off x="685800" y="1143000"/>
+            <a:ext cx="5486400" cy="3086100"/>
+          </a:xfrm>
+          <a:prstGeom prst="rect">
+            <a:avLst/>
+          </a:prstGeom>
+          <a:noFill/>
+          <a:ln w="12700">
+            <a:solidFill>
+              <a:prstClr val="black"/>
+            </a:solidFill>
+          </a:ln>
+        </p:spPr>
+        <p:txBody>
+          <a:bodyPr vert="horz" lIns="91440" tIns="45720" rIns="91440" bIns="45720" rtlCol="0" anchor="ctr"/>
+          <a:lstStyle/>
+          <a:p>
+            <a:endParaRPr lang="en-NZ"/>
+          </a:p>
+        </p:txBody>
+      </p:sp>
+      <p:sp>
+        <p:nvSpPr>
+          <p:cNvPr id="5" name="Notes Placeholder 4"/>
+          <p:cNvSpPr>
+            <a:spLocks noGrp="1"/>
+          </p:cNvSpPr>
+          <p:nvPr>
+            <p:ph type="body" sz="quarter" idx="3"/>
+          </p:nvPr>
+        </p:nvSpPr>
+        <p:spPr>
+          <a:xfrm>
+            <a:off x="685800" y="4400550"/>
+            <a:ext cx="5486400" cy="3600450"/>
+          </a:xfrm>
+          <a:prstGeom prst="rect">
+            <a:avLst/>
+          </a:prstGeom>
+        </p:spPr>
+        <p:txBody>
+          <a:bodyPr vert="horz" lIns="91440" tIns="45720" rIns="91440" bIns="45720" rtlCol="0"/>
+          <a:lstStyle/>
+          <a:p>
+            <a:pPr lvl="0"/>
+            <a:r>
+              <a:rPr lang="en-US"/>
+              <a:t>Click to edit Master text styles</a:t>
+            </a:r>
+          </a:p>
+          <a:p>
+            <a:pPr lvl="1"/>
+            <a:r>
+              <a:rPr lang="en-US"/>
+              <a:t>Second level</a:t>
+            </a:r>
+          </a:p>
+          <a:p>
+            <a:pPr lvl="2"/>
+            <a:r>
+              <a:rPr lang="en-US"/>
+              <a:t>Third level</a:t>
+            </a:r>
+          </a:p>
+          <a:p>
+            <a:pPr lvl="3"/>
+            <a:r>
+              <a:rPr lang="en-US"/>
+              <a:t>Fourth level</a:t>
+            </a:r>
+          </a:p>
+          <a:p>
+            <a:pPr lvl="4"/>
+            <a:r>
+              <a:rPr lang="en-US"/>
+              <a:t>Fifth level</a:t>
+            </a:r>
+            <a:endParaRPr lang="en-NZ"/>
+          </a:p>
+        </p:txBody>
+      </p:sp>
+      <p:sp>
+        <p:nvSpPr>
+          <p:cNvPr id="6" name="Footer Placeholder 5"/>
+          <p:cNvSpPr>
+            <a:spLocks noGrp="1"/>
+          </p:cNvSpPr>
+          <p:nvPr>
+            <p:ph type="ftr" sz="quarter" idx="4"/>
+          </p:nvPr>
+        </p:nvSpPr>
+        <p:spPr>
+          <a:xfrm>
+            <a:off x="0" y="8685213"/>
+            <a:ext cx="2971800" cy="458787"/>
+          </a:xfrm>
+          <a:prstGeom prst="rect">
+            <a:avLst/>
+          </a:prstGeom>
+        </p:spPr>
+        <p:txBody>
+          <a:bodyPr vert="horz" lIns="91440" tIns="45720" rIns="91440" bIns="45720" rtlCol="0" anchor="b"/>
+          <a:lstStyle>
+            <a:lvl1pPr algn="l">
+              <a:defRPr sz="1200"/>
+            </a:lvl1pPr>
+          </a:lstStyle>
+          <a:p>
+            <a:endParaRPr lang="en-NZ"/>
+          </a:p>
+        </p:txBody>
+      </p:sp>
+      <p:sp>
+        <p:nvSpPr>
+          <p:cNvPr id="7" name="Slide Number Placeholder 6"/>
+          <p:cNvSpPr>
+            <a:spLocks noGrp="1"/>
+          </p:cNvSpPr>
+          <p:nvPr>
+            <p:ph type="sldNum" sz="quarter" idx="5"/>
+          </p:nvPr>
+        </p:nvSpPr>
+        <p:spPr>
+          <a:xfrm>
+            <a:off x="3884613" y="8685213"/>
+            <a:ext cx="2971800" cy="458787"/>
+          </a:xfrm>
+          <a:prstGeom prst="rect">
+            <a:avLst/>
+          </a:prstGeom>
+        </p:spPr>
+        <p:txBody>
+          <a:bodyPr vert="horz" lIns="91440" tIns="45720" rIns="91440" bIns="45720" rtlCol="0" anchor="b"/>
+          <a:lstStyle>
+            <a:lvl1pPr algn="r">
+              <a:defRPr sz="1200"/>
+            </a:lvl1pPr>
+          </a:lstStyle>
+          <a:p>
+            <a:fld id="{824720C4-5235-4016-8938-54BD81D23C4F}" type="slidenum">
+              <a:rPr lang="en-NZ" smtClean="0"/>
+              <a:t>‹#›</a:t>
+            </a:fld>
+            <a:endParaRPr lang="en-NZ"/>
+          </a:p>
+        </p:txBody>
+      </p:sp>
+    </p:spTree>
+    <p:extLst>
+      <p:ext uri="{BB962C8B-B14F-4D97-AF65-F5344CB8AC3E}">
+        <p14:creationId xmlns:p14="http://schemas.microsoft.com/office/powerpoint/2010/main" val="1835474336"/>
+      </p:ext>
+    </p:extLst>
+  </p:cSld>
+  <p:clrMap bg1="lt1" tx1="dk1" bg2="lt2" tx2="dk2" accent1="accent1" accent2="accent2" accent3="accent3" accent4="accent4" accent5="accent5" accent6="accent6" hlink="hlink" folHlink="folHlink"/>
+  <p:notesStyle>
+    <a:lvl1pPr marL="0" algn="l" defTabSz="914400" rtl="0" eaLnBrk="1" latinLnBrk="0" hangingPunct="1">
+      <a:defRPr sz="1200" kern="1200">
+        <a:solidFill>
+          <a:schemeClr val="tx1"/>
+        </a:solidFill>
+        <a:latin typeface="+mn-lt"/>
+        <a:ea typeface="+mn-ea"/>
+        <a:cs typeface="+mn-cs"/>
+      </a:defRPr>
+    </a:lvl1pPr>
+    <a:lvl2pPr marL="457200" algn="l" defTabSz="914400" rtl="0" eaLnBrk="1" latinLnBrk="0" hangingPunct="1">
+      <a:defRPr sz="1200" kern="1200">
+        <a:solidFill>
+          <a:schemeClr val="tx1"/>
+        </a:solidFill>
+        <a:latin typeface="+mn-lt"/>
+        <a:ea typeface="+mn-ea"/>
+        <a:cs typeface="+mn-cs"/>
+      </a:defRPr>
+    </a:lvl2pPr>
+    <a:lvl3pPr marL="914400" algn="l" defTabSz="914400" rtl="0" eaLnBrk="1" latinLnBrk="0" hangingPunct="1">
+      <a:defRPr sz="1200" kern="1200">
+        <a:solidFill>
+          <a:schemeClr val="tx1"/>
+        </a:solidFill>
+        <a:latin typeface="+mn-lt"/>
+        <a:ea typeface="+mn-ea"/>
+        <a:cs typeface="+mn-cs"/>
+      </a:defRPr>
+    </a:lvl3pPr>
+    <a:lvl4pPr marL="1371600" algn="l" defTabSz="914400" rtl="0" eaLnBrk="1" latinLnBrk="0" hangingPunct="1">
+      <a:defRPr sz="1200" kern="1200">
+        <a:solidFill>
+          <a:schemeClr val="tx1"/>
+        </a:solidFill>
+        <a:latin typeface="+mn-lt"/>
+        <a:ea typeface="+mn-ea"/>
+        <a:cs typeface="+mn-cs"/>
+      </a:defRPr>
+    </a:lvl4pPr>
+    <a:lvl5pPr marL="1828800" algn="l" defTabSz="914400" rtl="0" eaLnBrk="1" latinLnBrk="0" hangingPunct="1">
+      <a:defRPr sz="1200" kern="1200">
+        <a:solidFill>
+          <a:schemeClr val="tx1"/>
+        </a:solidFill>
+        <a:latin typeface="+mn-lt"/>
+        <a:ea typeface="+mn-ea"/>
+        <a:cs typeface="+mn-cs"/>
+      </a:defRPr>
+    </a:lvl5pPr>
+    <a:lvl6pPr marL="2286000" algn="l" defTabSz="914400" rtl="0" eaLnBrk="1" latinLnBrk="0" hangingPunct="1">
+      <a:defRPr sz="1200" kern="1200">
+        <a:solidFill>
+          <a:schemeClr val="tx1"/>
+        </a:solidFill>
+        <a:latin typeface="+mn-lt"/>
+        <a:ea typeface="+mn-ea"/>
+        <a:cs typeface="+mn-cs"/>
+      </a:defRPr>
+    </a:lvl6pPr>
+    <a:lvl7pPr marL="2743200" algn="l" defTabSz="914400" rtl="0" eaLnBrk="1" latinLnBrk="0" hangingPunct="1">
+      <a:defRPr sz="1200" kern="1200">
+        <a:solidFill>
+          <a:schemeClr val="tx1"/>
+        </a:solidFill>
+        <a:latin typeface="+mn-lt"/>
+        <a:ea typeface="+mn-ea"/>
+        <a:cs typeface="+mn-cs"/>
+      </a:defRPr>
+    </a:lvl7pPr>
+    <a:lvl8pPr marL="3200400" algn="l" defTabSz="914400" rtl="0" eaLnBrk="1" latinLnBrk="0" hangingPunct="1">
+      <a:defRPr sz="1200" kern="1200">
+        <a:solidFill>
+          <a:schemeClr val="tx1"/>
+        </a:solidFill>
+        <a:latin typeface="+mn-lt"/>
+        <a:ea typeface="+mn-ea"/>
+        <a:cs typeface="+mn-cs"/>
+      </a:defRPr>
+    </a:lvl8pPr>
+    <a:lvl9pPr marL="3657600" algn="l" defTabSz="914400" rtl="0" eaLnBrk="1" latinLnBrk="0" hangingPunct="1">
+      <a:defRPr sz="1200" kern="1200">
+        <a:solidFill>
+          <a:schemeClr val="tx1"/>
+        </a:solidFill>
+        <a:latin typeface="+mn-lt"/>
+        <a:ea typeface="+mn-ea"/>
+        <a:cs typeface="+mn-cs"/>
+      </a:defRPr>
+    </a:lvl9pPr>
+  </p:notesStyle>
+</p:notesMaster>
 </file>
 
 <file path=ppt/slideLayouts/slideLayout1.xml><?xml version="1.0" encoding="utf-8"?>
@@ -256,7 +1152,7 @@
           <a:p>
             <a:fld id="{FD04AD32-8113-4A22-A841-1F9A67BEA3E5}" type="datetimeFigureOut">
               <a:rPr lang="en-NZ" smtClean="0"/>
-              <a:t>14/09/2026</a:t>
+              <a:t>18/09/2026</a:t>
             </a:fld>
             <a:endParaRPr lang="en-NZ"/>
           </a:p>
@@ -456,7 +1352,7 @@
           <a:p>
             <a:fld id="{FD04AD32-8113-4A22-A841-1F9A67BEA3E5}" type="datetimeFigureOut">
               <a:rPr lang="en-NZ" smtClean="0"/>
-              <a:t>14/09/2026</a:t>
+              <a:t>18/09/2026</a:t>
             </a:fld>
             <a:endParaRPr lang="en-NZ"/>
           </a:p>
@@ -666,7 +1562,7 @@
           <a:p>
             <a:fld id="{FD04AD32-8113-4A22-A841-1F9A67BEA3E5}" type="datetimeFigureOut">
               <a:rPr lang="en-NZ" smtClean="0"/>
-              <a:t>14/09/2026</a:t>
+              <a:t>18/09/2026</a:t>
             </a:fld>
             <a:endParaRPr lang="en-NZ"/>
           </a:p>
@@ -866,7 +1762,7 @@
           <a:p>
             <a:fld id="{FD04AD32-8113-4A22-A841-1F9A67BEA3E5}" type="datetimeFigureOut">
               <a:rPr lang="en-NZ" smtClean="0"/>
-              <a:t>14/09/2026</a:t>
+              <a:t>18/09/2026</a:t>
             </a:fld>
             <a:endParaRPr lang="en-NZ"/>
           </a:p>
@@ -1142,7 +2038,7 @@
           <a:p>
             <a:fld id="{FD04AD32-8113-4A22-A841-1F9A67BEA3E5}" type="datetimeFigureOut">
               <a:rPr lang="en-NZ" smtClean="0"/>
-              <a:t>14/09/2026</a:t>
+              <a:t>18/09/2026</a:t>
             </a:fld>
             <a:endParaRPr lang="en-NZ"/>
           </a:p>
@@ -1410,7 +2306,7 @@
           <a:p>
             <a:fld id="{FD04AD32-8113-4A22-A841-1F9A67BEA3E5}" type="datetimeFigureOut">
               <a:rPr lang="en-NZ" smtClean="0"/>
-              <a:t>14/09/2026</a:t>
+              <a:t>18/09/2026</a:t>
             </a:fld>
             <a:endParaRPr lang="en-NZ"/>
           </a:p>
@@ -1825,7 +2721,7 @@
           <a:p>
             <a:fld id="{FD04AD32-8113-4A22-A841-1F9A67BEA3E5}" type="datetimeFigureOut">
               <a:rPr lang="en-NZ" smtClean="0"/>
-              <a:t>14/09/2026</a:t>
+              <a:t>18/09/2026</a:t>
             </a:fld>
             <a:endParaRPr lang="en-NZ"/>
           </a:p>
@@ -1967,7 +2863,7 @@
           <a:p>
             <a:fld id="{FD04AD32-8113-4A22-A841-1F9A67BEA3E5}" type="datetimeFigureOut">
               <a:rPr lang="en-NZ" smtClean="0"/>
-              <a:t>14/09/2026</a:t>
+              <a:t>18/09/2026</a:t>
             </a:fld>
             <a:endParaRPr lang="en-NZ"/>
           </a:p>
@@ -2080,7 +2976,7 @@
           <a:p>
             <a:fld id="{FD04AD32-8113-4A22-A841-1F9A67BEA3E5}" type="datetimeFigureOut">
               <a:rPr lang="en-NZ" smtClean="0"/>
-              <a:t>14/09/2026</a:t>
+              <a:t>18/09/2026</a:t>
             </a:fld>
             <a:endParaRPr lang="en-NZ"/>
           </a:p>
@@ -2393,7 +3289,7 @@
           <a:p>
             <a:fld id="{FD04AD32-8113-4A22-A841-1F9A67BEA3E5}" type="datetimeFigureOut">
               <a:rPr lang="en-NZ" smtClean="0"/>
-              <a:t>14/09/2026</a:t>
+              <a:t>18/09/2026</a:t>
             </a:fld>
             <a:endParaRPr lang="en-NZ"/>
           </a:p>
@@ -2682,7 +3578,7 @@
           <a:p>
             <a:fld id="{FD04AD32-8113-4A22-A841-1F9A67BEA3E5}" type="datetimeFigureOut">
               <a:rPr lang="en-NZ" smtClean="0"/>
-              <a:t>14/09/2026</a:t>
+              <a:t>18/09/2026</a:t>
             </a:fld>
             <a:endParaRPr lang="en-NZ"/>
           </a:p>
@@ -2925,7 +3821,7 @@
           <a:p>
             <a:fld id="{FD04AD32-8113-4A22-A841-1F9A67BEA3E5}" type="datetimeFigureOut">
               <a:rPr lang="en-NZ" smtClean="0"/>
-              <a:t>14/09/2026</a:t>
+              <a:t>18/09/2026</a:t>
             </a:fld>
             <a:endParaRPr lang="en-NZ"/>
           </a:p>
@@ -3360,35 +4256,47 @@
         </p:nvSpPr>
         <p:spPr/>
         <p:txBody>
+          <a:bodyPr>
+            <a:normAutofit/>
+          </a:bodyPr>
+          <a:lstStyle/>
+          <a:p>
+            <a:r>
+              <a:rPr lang="en-NZ" sz="4800" dirty="0" err="1"/>
+              <a:t>SpringBoot</a:t>
+            </a:r>
+            <a:r>
+              <a:rPr lang="en-NZ" sz="4800" dirty="0"/>
+              <a:t> project with Vue.js</a:t>
+            </a:r>
+          </a:p>
+        </p:txBody>
+      </p:sp>
+      <p:sp>
+        <p:nvSpPr>
+          <p:cNvPr id="3" name="Subtitle 2">
+            <a:extLst>
+              <a:ext uri="{FF2B5EF4-FFF2-40B4-BE49-F238E27FC236}">
+                <a16:creationId xmlns:a16="http://schemas.microsoft.com/office/drawing/2014/main" id="{C187134A-548D-5FDC-7AAE-888AACFAAD5A}"/>
+              </a:ext>
+            </a:extLst>
+          </p:cNvPr>
+          <p:cNvSpPr>
+            <a:spLocks noGrp="1"/>
+          </p:cNvSpPr>
+          <p:nvPr>
+            <p:ph type="subTitle" idx="1"/>
+          </p:nvPr>
+        </p:nvSpPr>
+        <p:spPr/>
+        <p:txBody>
           <a:bodyPr/>
           <a:lstStyle/>
           <a:p>
-            <a:endParaRPr lang="en-NZ"/>
-          </a:p>
-        </p:txBody>
-      </p:sp>
-      <p:sp>
-        <p:nvSpPr>
-          <p:cNvPr id="3" name="Subtitle 2">
-            <a:extLst>
-              <a:ext uri="{FF2B5EF4-FFF2-40B4-BE49-F238E27FC236}">
-                <a16:creationId xmlns:a16="http://schemas.microsoft.com/office/drawing/2014/main" id="{C187134A-548D-5FDC-7AAE-888AACFAAD5A}"/>
-              </a:ext>
-            </a:extLst>
-          </p:cNvPr>
-          <p:cNvSpPr>
-            <a:spLocks noGrp="1"/>
-          </p:cNvSpPr>
-          <p:nvPr>
-            <p:ph type="subTitle" idx="1"/>
-          </p:nvPr>
-        </p:nvSpPr>
-        <p:spPr/>
-        <p:txBody>
-          <a:bodyPr/>
-          <a:lstStyle/>
-          <a:p>
-            <a:endParaRPr lang="en-NZ" dirty="0"/>
+            <a:r>
+              <a:rPr lang="en-NZ" dirty="0"/>
+              <a:t>Meeting 4</a:t>
+            </a:r>
           </a:p>
         </p:txBody>
       </p:sp>
@@ -3396,6 +4304,2146 @@
     <p:extLst>
       <p:ext uri="{BB962C8B-B14F-4D97-AF65-F5344CB8AC3E}">
         <p14:creationId xmlns:p14="http://schemas.microsoft.com/office/powerpoint/2010/main" val="3740703068"/>
+      </p:ext>
+    </p:extLst>
+  </p:cSld>
+  <p:clrMapOvr>
+    <a:masterClrMapping/>
+  </p:clrMapOvr>
+</p:sld>
+</file>
+
+<file path=ppt/slides/slide2.xml><?xml version="1.0" encoding="utf-8"?>
+<p:sld xmlns:a="http://schemas.openxmlformats.org/drawingml/2006/main" xmlns:r="http://schemas.openxmlformats.org/officeDocument/2006/relationships" xmlns:p="http://schemas.openxmlformats.org/presentationml/2006/main">
+  <p:cSld>
+    <p:spTree>
+      <p:nvGrpSpPr>
+        <p:cNvPr id="1" name=""/>
+        <p:cNvGrpSpPr/>
+        <p:nvPr/>
+      </p:nvGrpSpPr>
+      <p:grpSpPr>
+        <a:xfrm>
+          <a:off x="0" y="0"/>
+          <a:ext cx="0" cy="0"/>
+          <a:chOff x="0" y="0"/>
+          <a:chExt cx="0" cy="0"/>
+        </a:xfrm>
+      </p:grpSpPr>
+      <p:sp>
+        <p:nvSpPr>
+          <p:cNvPr id="2" name="Title 1">
+            <a:extLst>
+              <a:ext uri="{FF2B5EF4-FFF2-40B4-BE49-F238E27FC236}">
+                <a16:creationId xmlns:a16="http://schemas.microsoft.com/office/drawing/2014/main" id="{B862242E-0EEB-6570-EDBE-D39178A9D559}"/>
+              </a:ext>
+            </a:extLst>
+          </p:cNvPr>
+          <p:cNvSpPr>
+            <a:spLocks noGrp="1"/>
+          </p:cNvSpPr>
+          <p:nvPr>
+            <p:ph type="title"/>
+          </p:nvPr>
+        </p:nvSpPr>
+        <p:spPr>
+          <a:xfrm>
+            <a:off x="838200" y="140536"/>
+            <a:ext cx="10515600" cy="655878"/>
+          </a:xfrm>
+        </p:spPr>
+        <p:txBody>
+          <a:bodyPr>
+            <a:normAutofit/>
+          </a:bodyPr>
+          <a:lstStyle/>
+          <a:p>
+            <a:pPr algn="ctr"/>
+            <a:r>
+              <a:rPr lang="en-NZ" sz="4000" dirty="0"/>
+              <a:t>Environment and tools</a:t>
+            </a:r>
+          </a:p>
+        </p:txBody>
+      </p:sp>
+      <p:pic>
+        <p:nvPicPr>
+          <p:cNvPr id="8" name="Content Placeholder 7">
+            <a:extLst>
+              <a:ext uri="{FF2B5EF4-FFF2-40B4-BE49-F238E27FC236}">
+                <a16:creationId xmlns:a16="http://schemas.microsoft.com/office/drawing/2014/main" id="{9F32FF53-8827-866D-6545-4ED4C5A6A7DC}"/>
+              </a:ext>
+            </a:extLst>
+          </p:cNvPr>
+          <p:cNvPicPr>
+            <a:picLocks noGrp="1" noChangeAspect="1"/>
+          </p:cNvPicPr>
+          <p:nvPr>
+            <p:ph idx="1"/>
+          </p:nvPr>
+        </p:nvPicPr>
+        <p:blipFill>
+          <a:blip r:embed="rId2"/>
+          <a:stretch>
+            <a:fillRect/>
+          </a:stretch>
+        </p:blipFill>
+        <p:spPr>
+          <a:xfrm>
+            <a:off x="233175" y="796414"/>
+            <a:ext cx="3766376" cy="3626361"/>
+          </a:xfrm>
+          <a:prstGeom prst="rect">
+            <a:avLst/>
+          </a:prstGeom>
+        </p:spPr>
+      </p:pic>
+      <mc:AlternateContent xmlns:mc="http://schemas.openxmlformats.org/markup-compatibility/2006" xmlns:p14="http://schemas.microsoft.com/office/powerpoint/2010/main">
+        <mc:Choice Requires="p14">
+          <p:contentPart p14:bwMode="auto" r:id="rId3">
+            <p14:nvContentPartPr>
+              <p14:cNvPr id="11" name="Ink 10">
+                <a:extLst>
+                  <a:ext uri="{FF2B5EF4-FFF2-40B4-BE49-F238E27FC236}">
+                    <a16:creationId xmlns:a16="http://schemas.microsoft.com/office/drawing/2014/main" id="{1EBEBDD0-6B77-AF11-85C4-0BBE6F1F58F2}"/>
+                  </a:ext>
+                </a:extLst>
+              </p14:cNvPr>
+              <p14:cNvContentPartPr/>
+              <p14:nvPr/>
+            </p14:nvContentPartPr>
+            <p14:xfrm>
+              <a:off x="632080" y="2826511"/>
+              <a:ext cx="1971360" cy="420840"/>
+            </p14:xfrm>
+          </p:contentPart>
+        </mc:Choice>
+        <mc:Fallback xmlns="">
+          <p:pic>
+            <p:nvPicPr>
+              <p:cNvPr id="11" name="Ink 10">
+                <a:extLst>
+                  <a:ext uri="{FF2B5EF4-FFF2-40B4-BE49-F238E27FC236}">
+                    <a16:creationId xmlns:a16="http://schemas.microsoft.com/office/drawing/2014/main" id="{1EBEBDD0-6B77-AF11-85C4-0BBE6F1F58F2}"/>
+                  </a:ext>
+                </a:extLst>
+              </p:cNvPr>
+              <p:cNvPicPr/>
+              <p:nvPr/>
+            </p:nvPicPr>
+            <p:blipFill>
+              <a:blip r:embed="rId4"/>
+              <a:stretch>
+                <a:fillRect/>
+              </a:stretch>
+            </p:blipFill>
+            <p:spPr>
+              <a:xfrm>
+                <a:off x="625960" y="2820391"/>
+                <a:ext cx="1983600" cy="433080"/>
+              </a:xfrm>
+              <a:prstGeom prst="rect">
+                <a:avLst/>
+              </a:prstGeom>
+            </p:spPr>
+          </p:pic>
+        </mc:Fallback>
+      </mc:AlternateContent>
+      <p:pic>
+        <p:nvPicPr>
+          <p:cNvPr id="13" name="Picture 12">
+            <a:extLst>
+              <a:ext uri="{FF2B5EF4-FFF2-40B4-BE49-F238E27FC236}">
+                <a16:creationId xmlns:a16="http://schemas.microsoft.com/office/drawing/2014/main" id="{E6668C4D-9BE2-D873-EFE0-AA0FE765A9D6}"/>
+              </a:ext>
+            </a:extLst>
+          </p:cNvPr>
+          <p:cNvPicPr>
+            <a:picLocks noChangeAspect="1"/>
+          </p:cNvPicPr>
+          <p:nvPr/>
+        </p:nvPicPr>
+        <p:blipFill>
+          <a:blip r:embed="rId5"/>
+          <a:stretch>
+            <a:fillRect/>
+          </a:stretch>
+        </p:blipFill>
+        <p:spPr>
+          <a:xfrm>
+            <a:off x="4368959" y="796414"/>
+            <a:ext cx="7589866" cy="3626361"/>
+          </a:xfrm>
+          <a:prstGeom prst="rect">
+            <a:avLst/>
+          </a:prstGeom>
+        </p:spPr>
+      </p:pic>
+      <p:sp>
+        <p:nvSpPr>
+          <p:cNvPr id="14" name="TextBox 13">
+            <a:extLst>
+              <a:ext uri="{FF2B5EF4-FFF2-40B4-BE49-F238E27FC236}">
+                <a16:creationId xmlns:a16="http://schemas.microsoft.com/office/drawing/2014/main" id="{308AFD9C-F48E-730E-C62B-F0D38320809B}"/>
+              </a:ext>
+            </a:extLst>
+          </p:cNvPr>
+          <p:cNvSpPr txBox="1"/>
+          <p:nvPr/>
+        </p:nvSpPr>
+        <p:spPr>
+          <a:xfrm>
+            <a:off x="6096000" y="813899"/>
+            <a:ext cx="2772697" cy="523220"/>
+          </a:xfrm>
+          <a:prstGeom prst="rect">
+            <a:avLst/>
+          </a:prstGeom>
+          <a:noFill/>
+        </p:spPr>
+        <p:txBody>
+          <a:bodyPr wrap="square" rtlCol="0">
+            <a:spAutoFit/>
+          </a:bodyPr>
+          <a:lstStyle/>
+          <a:p>
+            <a:r>
+              <a:rPr lang="en-NZ" sz="2800" dirty="0">
+                <a:solidFill>
+                  <a:srgbClr val="FF0000"/>
+                </a:solidFill>
+              </a:rPr>
+              <a:t>GitHub tool</a:t>
+            </a:r>
+          </a:p>
+        </p:txBody>
+      </p:sp>
+      <p:pic>
+        <p:nvPicPr>
+          <p:cNvPr id="47" name="Picture 46">
+            <a:extLst>
+              <a:ext uri="{FF2B5EF4-FFF2-40B4-BE49-F238E27FC236}">
+                <a16:creationId xmlns:a16="http://schemas.microsoft.com/office/drawing/2014/main" id="{E292E58E-0C4E-2A58-EE2F-81F9EE09327C}"/>
+              </a:ext>
+            </a:extLst>
+          </p:cNvPr>
+          <p:cNvPicPr>
+            <a:picLocks noChangeAspect="1"/>
+          </p:cNvPicPr>
+          <p:nvPr/>
+        </p:nvPicPr>
+        <p:blipFill>
+          <a:blip r:embed="rId6"/>
+          <a:stretch>
+            <a:fillRect/>
+          </a:stretch>
+        </p:blipFill>
+        <p:spPr>
+          <a:xfrm>
+            <a:off x="233175" y="4567112"/>
+            <a:ext cx="11725650" cy="1130451"/>
+          </a:xfrm>
+          <a:prstGeom prst="rect">
+            <a:avLst/>
+          </a:prstGeom>
+        </p:spPr>
+      </p:pic>
+      <mc:AlternateContent xmlns:mc="http://schemas.openxmlformats.org/markup-compatibility/2006" xmlns:p14="http://schemas.microsoft.com/office/powerpoint/2010/main">
+        <mc:Choice Requires="p14">
+          <p:contentPart p14:bwMode="auto" r:id="rId7">
+            <p14:nvContentPartPr>
+              <p14:cNvPr id="50" name="Ink 49">
+                <a:extLst>
+                  <a:ext uri="{FF2B5EF4-FFF2-40B4-BE49-F238E27FC236}">
+                    <a16:creationId xmlns:a16="http://schemas.microsoft.com/office/drawing/2014/main" id="{8CE2B9D3-F33A-34AB-1387-E140BDEB0921}"/>
+                  </a:ext>
+                </a:extLst>
+              </p14:cNvPr>
+              <p14:cNvContentPartPr/>
+              <p14:nvPr/>
+            </p14:nvContentPartPr>
+            <p14:xfrm>
+              <a:off x="294201" y="5323831"/>
+              <a:ext cx="1814760" cy="29520"/>
+            </p14:xfrm>
+          </p:contentPart>
+        </mc:Choice>
+        <mc:Fallback xmlns="">
+          <p:pic>
+            <p:nvPicPr>
+              <p:cNvPr id="50" name="Ink 49">
+                <a:extLst>
+                  <a:ext uri="{FF2B5EF4-FFF2-40B4-BE49-F238E27FC236}">
+                    <a16:creationId xmlns:a16="http://schemas.microsoft.com/office/drawing/2014/main" id="{8CE2B9D3-F33A-34AB-1387-E140BDEB0921}"/>
+                  </a:ext>
+                </a:extLst>
+              </p:cNvPr>
+              <p:cNvPicPr/>
+              <p:nvPr/>
+            </p:nvPicPr>
+            <p:blipFill>
+              <a:blip r:embed="rId8"/>
+              <a:stretch>
+                <a:fillRect/>
+              </a:stretch>
+            </p:blipFill>
+            <p:spPr>
+              <a:xfrm>
+                <a:off x="288081" y="5317711"/>
+                <a:ext cx="1827000" cy="41760"/>
+              </a:xfrm>
+              <a:prstGeom prst="rect">
+                <a:avLst/>
+              </a:prstGeom>
+            </p:spPr>
+          </p:pic>
+        </mc:Fallback>
+      </mc:AlternateContent>
+      <mc:AlternateContent xmlns:mc="http://schemas.openxmlformats.org/markup-compatibility/2006" xmlns:p14="http://schemas.microsoft.com/office/powerpoint/2010/main">
+        <mc:Choice Requires="p14">
+          <p:contentPart p14:bwMode="auto" r:id="rId9">
+            <p14:nvContentPartPr>
+              <p14:cNvPr id="51" name="Ink 50">
+                <a:extLst>
+                  <a:ext uri="{FF2B5EF4-FFF2-40B4-BE49-F238E27FC236}">
+                    <a16:creationId xmlns:a16="http://schemas.microsoft.com/office/drawing/2014/main" id="{AAC50E1A-B632-3892-B9F6-C47B57CA3AA4}"/>
+                  </a:ext>
+                </a:extLst>
+              </p14:cNvPr>
+              <p14:cNvContentPartPr/>
+              <p14:nvPr/>
+            </p14:nvContentPartPr>
+            <p14:xfrm>
+              <a:off x="2108601" y="5168671"/>
+              <a:ext cx="15480" cy="155520"/>
+            </p14:xfrm>
+          </p:contentPart>
+        </mc:Choice>
+        <mc:Fallback xmlns="">
+          <p:pic>
+            <p:nvPicPr>
+              <p:cNvPr id="51" name="Ink 50">
+                <a:extLst>
+                  <a:ext uri="{FF2B5EF4-FFF2-40B4-BE49-F238E27FC236}">
+                    <a16:creationId xmlns:a16="http://schemas.microsoft.com/office/drawing/2014/main" id="{AAC50E1A-B632-3892-B9F6-C47B57CA3AA4}"/>
+                  </a:ext>
+                </a:extLst>
+              </p:cNvPr>
+              <p:cNvPicPr/>
+              <p:nvPr/>
+            </p:nvPicPr>
+            <p:blipFill>
+              <a:blip r:embed="rId10"/>
+              <a:stretch>
+                <a:fillRect/>
+              </a:stretch>
+            </p:blipFill>
+            <p:spPr>
+              <a:xfrm>
+                <a:off x="2102481" y="5162551"/>
+                <a:ext cx="27720" cy="167760"/>
+              </a:xfrm>
+              <a:prstGeom prst="rect">
+                <a:avLst/>
+              </a:prstGeom>
+            </p:spPr>
+          </p:pic>
+        </mc:Fallback>
+      </mc:AlternateContent>
+      <mc:AlternateContent xmlns:mc="http://schemas.openxmlformats.org/markup-compatibility/2006" xmlns:p14="http://schemas.microsoft.com/office/powerpoint/2010/main">
+        <mc:Choice Requires="p14">
+          <p:contentPart p14:bwMode="auto" r:id="rId11">
+            <p14:nvContentPartPr>
+              <p14:cNvPr id="53" name="Ink 52">
+                <a:extLst>
+                  <a:ext uri="{FF2B5EF4-FFF2-40B4-BE49-F238E27FC236}">
+                    <a16:creationId xmlns:a16="http://schemas.microsoft.com/office/drawing/2014/main" id="{A4CFDE75-760C-8E64-A005-3CE1DCA33EA4}"/>
+                  </a:ext>
+                </a:extLst>
+              </p14:cNvPr>
+              <p14:cNvContentPartPr/>
+              <p14:nvPr/>
+            </p14:nvContentPartPr>
+            <p14:xfrm>
+              <a:off x="294201" y="5146711"/>
+              <a:ext cx="1829520" cy="360"/>
+            </p14:xfrm>
+          </p:contentPart>
+        </mc:Choice>
+        <mc:Fallback xmlns="">
+          <p:pic>
+            <p:nvPicPr>
+              <p:cNvPr id="53" name="Ink 52">
+                <a:extLst>
+                  <a:ext uri="{FF2B5EF4-FFF2-40B4-BE49-F238E27FC236}">
+                    <a16:creationId xmlns:a16="http://schemas.microsoft.com/office/drawing/2014/main" id="{A4CFDE75-760C-8E64-A005-3CE1DCA33EA4}"/>
+                  </a:ext>
+                </a:extLst>
+              </p:cNvPr>
+              <p:cNvPicPr/>
+              <p:nvPr/>
+            </p:nvPicPr>
+            <p:blipFill>
+              <a:blip r:embed="rId12"/>
+              <a:stretch>
+                <a:fillRect/>
+              </a:stretch>
+            </p:blipFill>
+            <p:spPr>
+              <a:xfrm>
+                <a:off x="288081" y="5140591"/>
+                <a:ext cx="1841760" cy="12600"/>
+              </a:xfrm>
+              <a:prstGeom prst="rect">
+                <a:avLst/>
+              </a:prstGeom>
+            </p:spPr>
+          </p:pic>
+        </mc:Fallback>
+      </mc:AlternateContent>
+      <mc:AlternateContent xmlns:mc="http://schemas.openxmlformats.org/markup-compatibility/2006" xmlns:p14="http://schemas.microsoft.com/office/powerpoint/2010/main">
+        <mc:Choice Requires="p14">
+          <p:contentPart p14:bwMode="auto" r:id="rId13">
+            <p14:nvContentPartPr>
+              <p14:cNvPr id="54" name="Ink 53">
+                <a:extLst>
+                  <a:ext uri="{FF2B5EF4-FFF2-40B4-BE49-F238E27FC236}">
+                    <a16:creationId xmlns:a16="http://schemas.microsoft.com/office/drawing/2014/main" id="{F8380AD8-5D12-6326-0F99-FB88AB6463A7}"/>
+                  </a:ext>
+                </a:extLst>
+              </p14:cNvPr>
+              <p14:cNvContentPartPr/>
+              <p14:nvPr/>
+            </p14:nvContentPartPr>
+            <p14:xfrm>
+              <a:off x="249561" y="5146711"/>
+              <a:ext cx="22320" cy="219960"/>
+            </p14:xfrm>
+          </p:contentPart>
+        </mc:Choice>
+        <mc:Fallback xmlns="">
+          <p:pic>
+            <p:nvPicPr>
+              <p:cNvPr id="54" name="Ink 53">
+                <a:extLst>
+                  <a:ext uri="{FF2B5EF4-FFF2-40B4-BE49-F238E27FC236}">
+                    <a16:creationId xmlns:a16="http://schemas.microsoft.com/office/drawing/2014/main" id="{F8380AD8-5D12-6326-0F99-FB88AB6463A7}"/>
+                  </a:ext>
+                </a:extLst>
+              </p:cNvPr>
+              <p:cNvPicPr/>
+              <p:nvPr/>
+            </p:nvPicPr>
+            <p:blipFill>
+              <a:blip r:embed="rId14"/>
+              <a:stretch>
+                <a:fillRect/>
+              </a:stretch>
+            </p:blipFill>
+            <p:spPr>
+              <a:xfrm>
+                <a:off x="243441" y="5140591"/>
+                <a:ext cx="34560" cy="232200"/>
+              </a:xfrm>
+              <a:prstGeom prst="rect">
+                <a:avLst/>
+              </a:prstGeom>
+            </p:spPr>
+          </p:pic>
+        </mc:Fallback>
+      </mc:AlternateContent>
+      <mc:AlternateContent xmlns:mc="http://schemas.openxmlformats.org/markup-compatibility/2006" xmlns:p14="http://schemas.microsoft.com/office/powerpoint/2010/main">
+        <mc:Choice Requires="p14">
+          <p:contentPart p14:bwMode="auto" r:id="rId15">
+            <p14:nvContentPartPr>
+              <p14:cNvPr id="58" name="Ink 57">
+                <a:extLst>
+                  <a:ext uri="{FF2B5EF4-FFF2-40B4-BE49-F238E27FC236}">
+                    <a16:creationId xmlns:a16="http://schemas.microsoft.com/office/drawing/2014/main" id="{1C84BB87-1F0A-33E8-72E1-E74EDCC8B194}"/>
+                  </a:ext>
+                </a:extLst>
+              </p14:cNvPr>
+              <p14:cNvContentPartPr/>
+              <p14:nvPr/>
+            </p14:nvContentPartPr>
+            <p14:xfrm>
+              <a:off x="279801" y="4999111"/>
+              <a:ext cx="1741320" cy="720"/>
+            </p14:xfrm>
+          </p:contentPart>
+        </mc:Choice>
+        <mc:Fallback xmlns="">
+          <p:pic>
+            <p:nvPicPr>
+              <p:cNvPr id="58" name="Ink 57">
+                <a:extLst>
+                  <a:ext uri="{FF2B5EF4-FFF2-40B4-BE49-F238E27FC236}">
+                    <a16:creationId xmlns:a16="http://schemas.microsoft.com/office/drawing/2014/main" id="{1C84BB87-1F0A-33E8-72E1-E74EDCC8B194}"/>
+                  </a:ext>
+                </a:extLst>
+              </p:cNvPr>
+              <p:cNvPicPr/>
+              <p:nvPr/>
+            </p:nvPicPr>
+            <p:blipFill>
+              <a:blip r:embed="rId16"/>
+              <a:stretch>
+                <a:fillRect/>
+              </a:stretch>
+            </p:blipFill>
+            <p:spPr>
+              <a:xfrm>
+                <a:off x="273681" y="4986871"/>
+                <a:ext cx="1753560" cy="25200"/>
+              </a:xfrm>
+              <a:prstGeom prst="rect">
+                <a:avLst/>
+              </a:prstGeom>
+            </p:spPr>
+          </p:pic>
+        </mc:Fallback>
+      </mc:AlternateContent>
+      <mc:AlternateContent xmlns:mc="http://schemas.openxmlformats.org/markup-compatibility/2006" xmlns:p14="http://schemas.microsoft.com/office/powerpoint/2010/main">
+        <mc:Choice Requires="p14">
+          <p:contentPart p14:bwMode="auto" r:id="rId17">
+            <p14:nvContentPartPr>
+              <p14:cNvPr id="59" name="Ink 58">
+                <a:extLst>
+                  <a:ext uri="{FF2B5EF4-FFF2-40B4-BE49-F238E27FC236}">
+                    <a16:creationId xmlns:a16="http://schemas.microsoft.com/office/drawing/2014/main" id="{00B637F4-7082-A058-4597-C576B212BF93}"/>
+                  </a:ext>
+                </a:extLst>
+              </p14:cNvPr>
+              <p14:cNvContentPartPr/>
+              <p14:nvPr/>
+            </p14:nvContentPartPr>
+            <p14:xfrm>
+              <a:off x="2035161" y="4823791"/>
+              <a:ext cx="360" cy="146520"/>
+            </p14:xfrm>
+          </p:contentPart>
+        </mc:Choice>
+        <mc:Fallback xmlns="">
+          <p:pic>
+            <p:nvPicPr>
+              <p:cNvPr id="59" name="Ink 58">
+                <a:extLst>
+                  <a:ext uri="{FF2B5EF4-FFF2-40B4-BE49-F238E27FC236}">
+                    <a16:creationId xmlns:a16="http://schemas.microsoft.com/office/drawing/2014/main" id="{00B637F4-7082-A058-4597-C576B212BF93}"/>
+                  </a:ext>
+                </a:extLst>
+              </p:cNvPr>
+              <p:cNvPicPr/>
+              <p:nvPr/>
+            </p:nvPicPr>
+            <p:blipFill>
+              <a:blip r:embed="rId18"/>
+              <a:stretch>
+                <a:fillRect/>
+              </a:stretch>
+            </p:blipFill>
+            <p:spPr>
+              <a:xfrm>
+                <a:off x="2029041" y="4817671"/>
+                <a:ext cx="12600" cy="158760"/>
+              </a:xfrm>
+              <a:prstGeom prst="rect">
+                <a:avLst/>
+              </a:prstGeom>
+            </p:spPr>
+          </p:pic>
+        </mc:Fallback>
+      </mc:AlternateContent>
+      <mc:AlternateContent xmlns:mc="http://schemas.openxmlformats.org/markup-compatibility/2006" xmlns:p14="http://schemas.microsoft.com/office/powerpoint/2010/main">
+        <mc:Choice Requires="p14">
+          <p:contentPart p14:bwMode="auto" r:id="rId19">
+            <p14:nvContentPartPr>
+              <p14:cNvPr id="61" name="Ink 60">
+                <a:extLst>
+                  <a:ext uri="{FF2B5EF4-FFF2-40B4-BE49-F238E27FC236}">
+                    <a16:creationId xmlns:a16="http://schemas.microsoft.com/office/drawing/2014/main" id="{1D1EF151-CA22-B097-F353-BB25581F3BFF}"/>
+                  </a:ext>
+                </a:extLst>
+              </p14:cNvPr>
+              <p14:cNvContentPartPr/>
+              <p14:nvPr/>
+            </p14:nvContentPartPr>
+            <p14:xfrm>
+              <a:off x="250281" y="4778431"/>
+              <a:ext cx="1785240" cy="14760"/>
+            </p14:xfrm>
+          </p:contentPart>
+        </mc:Choice>
+        <mc:Fallback xmlns="">
+          <p:pic>
+            <p:nvPicPr>
+              <p:cNvPr id="61" name="Ink 60">
+                <a:extLst>
+                  <a:ext uri="{FF2B5EF4-FFF2-40B4-BE49-F238E27FC236}">
+                    <a16:creationId xmlns:a16="http://schemas.microsoft.com/office/drawing/2014/main" id="{1D1EF151-CA22-B097-F353-BB25581F3BFF}"/>
+                  </a:ext>
+                </a:extLst>
+              </p:cNvPr>
+              <p:cNvPicPr/>
+              <p:nvPr/>
+            </p:nvPicPr>
+            <p:blipFill>
+              <a:blip r:embed="rId20"/>
+              <a:stretch>
+                <a:fillRect/>
+              </a:stretch>
+            </p:blipFill>
+            <p:spPr>
+              <a:xfrm>
+                <a:off x="244161" y="4772311"/>
+                <a:ext cx="1797480" cy="27000"/>
+              </a:xfrm>
+              <a:prstGeom prst="rect">
+                <a:avLst/>
+              </a:prstGeom>
+            </p:spPr>
+          </p:pic>
+        </mc:Fallback>
+      </mc:AlternateContent>
+      <mc:AlternateContent xmlns:mc="http://schemas.openxmlformats.org/markup-compatibility/2006" xmlns:p14="http://schemas.microsoft.com/office/powerpoint/2010/main">
+        <mc:Choice Requires="p14">
+          <p:contentPart p14:bwMode="auto" r:id="rId21">
+            <p14:nvContentPartPr>
+              <p14:cNvPr id="62" name="Ink 61">
+                <a:extLst>
+                  <a:ext uri="{FF2B5EF4-FFF2-40B4-BE49-F238E27FC236}">
+                    <a16:creationId xmlns:a16="http://schemas.microsoft.com/office/drawing/2014/main" id="{084F1B85-3176-BF22-A3CE-1174A0CFA1EC}"/>
+                  </a:ext>
+                </a:extLst>
+              </p14:cNvPr>
+              <p14:cNvContentPartPr/>
+              <p14:nvPr/>
+            </p14:nvContentPartPr>
+            <p14:xfrm>
+              <a:off x="250281" y="4778431"/>
+              <a:ext cx="18000" cy="222840"/>
+            </p14:xfrm>
+          </p:contentPart>
+        </mc:Choice>
+        <mc:Fallback xmlns="">
+          <p:pic>
+            <p:nvPicPr>
+              <p:cNvPr id="62" name="Ink 61">
+                <a:extLst>
+                  <a:ext uri="{FF2B5EF4-FFF2-40B4-BE49-F238E27FC236}">
+                    <a16:creationId xmlns:a16="http://schemas.microsoft.com/office/drawing/2014/main" id="{084F1B85-3176-BF22-A3CE-1174A0CFA1EC}"/>
+                  </a:ext>
+                </a:extLst>
+              </p:cNvPr>
+              <p:cNvPicPr/>
+              <p:nvPr/>
+            </p:nvPicPr>
+            <p:blipFill>
+              <a:blip r:embed="rId22"/>
+              <a:stretch>
+                <a:fillRect/>
+              </a:stretch>
+            </p:blipFill>
+            <p:spPr>
+              <a:xfrm>
+                <a:off x="244161" y="4772311"/>
+                <a:ext cx="30240" cy="235080"/>
+              </a:xfrm>
+              <a:prstGeom prst="rect">
+                <a:avLst/>
+              </a:prstGeom>
+            </p:spPr>
+          </p:pic>
+        </mc:Fallback>
+      </mc:AlternateContent>
+      <p:sp>
+        <p:nvSpPr>
+          <p:cNvPr id="63" name="TextBox 62">
+            <a:extLst>
+              <a:ext uri="{FF2B5EF4-FFF2-40B4-BE49-F238E27FC236}">
+                <a16:creationId xmlns:a16="http://schemas.microsoft.com/office/drawing/2014/main" id="{B2F8D031-4316-C437-EF44-94EB862FF1EC}"/>
+              </a:ext>
+            </a:extLst>
+          </p:cNvPr>
+          <p:cNvSpPr txBox="1"/>
+          <p:nvPr/>
+        </p:nvSpPr>
+        <p:spPr>
+          <a:xfrm>
+            <a:off x="233175" y="5742536"/>
+            <a:ext cx="9911683" cy="646331"/>
+          </a:xfrm>
+          <a:prstGeom prst="rect">
+            <a:avLst/>
+          </a:prstGeom>
+          <a:noFill/>
+        </p:spPr>
+        <p:txBody>
+          <a:bodyPr wrap="square" rtlCol="0">
+            <a:spAutoFit/>
+          </a:bodyPr>
+          <a:lstStyle/>
+          <a:p>
+            <a:r>
+              <a:rPr lang="en-US" altLang="zh-CN" dirty="0"/>
+              <a:t>Maven Tool Version: 3.9.16</a:t>
+            </a:r>
+          </a:p>
+          <a:p>
+            <a:r>
+              <a:rPr lang="en-NZ" dirty="0"/>
+              <a:t>Java </a:t>
+            </a:r>
+            <a:r>
+              <a:rPr lang="en-US" altLang="zh-CN" dirty="0"/>
+              <a:t>Environment Version: 21.0.9</a:t>
+            </a:r>
+            <a:endParaRPr lang="en-NZ" dirty="0"/>
+          </a:p>
+        </p:txBody>
+      </p:sp>
+    </p:spTree>
+    <p:extLst>
+      <p:ext uri="{BB962C8B-B14F-4D97-AF65-F5344CB8AC3E}">
+        <p14:creationId xmlns:p14="http://schemas.microsoft.com/office/powerpoint/2010/main" val="100790330"/>
+      </p:ext>
+    </p:extLst>
+  </p:cSld>
+  <p:clrMapOvr>
+    <a:masterClrMapping/>
+  </p:clrMapOvr>
+</p:sld>
+</file>
+
+<file path=ppt/slides/slide3.xml><?xml version="1.0" encoding="utf-8"?>
+<p:sld xmlns:a="http://schemas.openxmlformats.org/drawingml/2006/main" xmlns:r="http://schemas.openxmlformats.org/officeDocument/2006/relationships" xmlns:p="http://schemas.openxmlformats.org/presentationml/2006/main">
+  <p:cSld>
+    <p:spTree>
+      <p:nvGrpSpPr>
+        <p:cNvPr id="1" name=""/>
+        <p:cNvGrpSpPr/>
+        <p:nvPr/>
+      </p:nvGrpSpPr>
+      <p:grpSpPr>
+        <a:xfrm>
+          <a:off x="0" y="0"/>
+          <a:ext cx="0" cy="0"/>
+          <a:chOff x="0" y="0"/>
+          <a:chExt cx="0" cy="0"/>
+        </a:xfrm>
+      </p:grpSpPr>
+      <p:sp>
+        <p:nvSpPr>
+          <p:cNvPr id="2" name="Title 1">
+            <a:extLst>
+              <a:ext uri="{FF2B5EF4-FFF2-40B4-BE49-F238E27FC236}">
+                <a16:creationId xmlns:a16="http://schemas.microsoft.com/office/drawing/2014/main" id="{389C5055-32B4-F57A-43F3-CAB867C1E59F}"/>
+              </a:ext>
+            </a:extLst>
+          </p:cNvPr>
+          <p:cNvSpPr>
+            <a:spLocks noGrp="1"/>
+          </p:cNvSpPr>
+          <p:nvPr>
+            <p:ph type="title"/>
+          </p:nvPr>
+        </p:nvSpPr>
+        <p:spPr>
+          <a:xfrm>
+            <a:off x="838200" y="365125"/>
+            <a:ext cx="10515600" cy="623017"/>
+          </a:xfrm>
+        </p:spPr>
+        <p:txBody>
+          <a:bodyPr>
+            <a:normAutofit/>
+          </a:bodyPr>
+          <a:lstStyle/>
+          <a:p>
+            <a:r>
+              <a:rPr lang="en-NZ" sz="3200" dirty="0"/>
+              <a:t>pom.xml: Maven </a:t>
+            </a:r>
+            <a:r>
+              <a:rPr lang="en-NZ" sz="3200" dirty="0" err="1"/>
+              <a:t>项目的核心配置文件</a:t>
+            </a:r>
+            <a:endParaRPr lang="en-NZ" sz="3200" dirty="0"/>
+          </a:p>
+        </p:txBody>
+      </p:sp>
+      <p:pic>
+        <p:nvPicPr>
+          <p:cNvPr id="5" name="Content Placeholder 4">
+            <a:extLst>
+              <a:ext uri="{FF2B5EF4-FFF2-40B4-BE49-F238E27FC236}">
+                <a16:creationId xmlns:a16="http://schemas.microsoft.com/office/drawing/2014/main" id="{E4D0411D-6EB3-DC13-1F8A-15A47820ABA4}"/>
+              </a:ext>
+            </a:extLst>
+          </p:cNvPr>
+          <p:cNvPicPr>
+            <a:picLocks noGrp="1" noChangeAspect="1"/>
+          </p:cNvPicPr>
+          <p:nvPr>
+            <p:ph idx="1"/>
+          </p:nvPr>
+        </p:nvPicPr>
+        <p:blipFill>
+          <a:blip r:embed="rId2"/>
+          <a:srcRect l="8719"/>
+          <a:stretch>
+            <a:fillRect/>
+          </a:stretch>
+        </p:blipFill>
+        <p:spPr>
+          <a:xfrm>
+            <a:off x="838200" y="1407322"/>
+            <a:ext cx="10515600" cy="4941489"/>
+          </a:xfrm>
+          <a:prstGeom prst="rect">
+            <a:avLst/>
+          </a:prstGeom>
+        </p:spPr>
+      </p:pic>
+      <mc:AlternateContent xmlns:mc="http://schemas.openxmlformats.org/markup-compatibility/2006" xmlns:p14="http://schemas.microsoft.com/office/powerpoint/2010/main">
+        <mc:Choice Requires="p14">
+          <p:contentPart p14:bwMode="auto" r:id="rId3">
+            <p14:nvContentPartPr>
+              <p14:cNvPr id="6" name="Ink 5">
+                <a:extLst>
+                  <a:ext uri="{FF2B5EF4-FFF2-40B4-BE49-F238E27FC236}">
+                    <a16:creationId xmlns:a16="http://schemas.microsoft.com/office/drawing/2014/main" id="{4C78B95D-5BE3-977D-81D4-FA35DCFA1D53}"/>
+                  </a:ext>
+                </a:extLst>
+              </p14:cNvPr>
+              <p14:cNvContentPartPr/>
+              <p14:nvPr/>
+            </p14:nvContentPartPr>
+            <p14:xfrm>
+              <a:off x="1972080" y="5860291"/>
+              <a:ext cx="1317600" cy="348780"/>
+            </p14:xfrm>
+          </p:contentPart>
+        </mc:Choice>
+        <mc:Fallback xmlns="">
+          <p:pic>
+            <p:nvPicPr>
+              <p:cNvPr id="6" name="Ink 5">
+                <a:extLst>
+                  <a:ext uri="{FF2B5EF4-FFF2-40B4-BE49-F238E27FC236}">
+                    <a16:creationId xmlns:a16="http://schemas.microsoft.com/office/drawing/2014/main" id="{4C78B95D-5BE3-977D-81D4-FA35DCFA1D53}"/>
+                  </a:ext>
+                </a:extLst>
+              </p:cNvPr>
+              <p:cNvPicPr/>
+              <p:nvPr/>
+            </p:nvPicPr>
+            <p:blipFill>
+              <a:blip r:embed="rId4"/>
+              <a:stretch>
+                <a:fillRect/>
+              </a:stretch>
+            </p:blipFill>
+            <p:spPr>
+              <a:xfrm>
+                <a:off x="1965960" y="5854172"/>
+                <a:ext cx="1329840" cy="361018"/>
+              </a:xfrm>
+              <a:prstGeom prst="rect">
+                <a:avLst/>
+              </a:prstGeom>
+            </p:spPr>
+          </p:pic>
+        </mc:Fallback>
+      </mc:AlternateContent>
+    </p:spTree>
+    <p:extLst>
+      <p:ext uri="{BB962C8B-B14F-4D97-AF65-F5344CB8AC3E}">
+        <p14:creationId xmlns:p14="http://schemas.microsoft.com/office/powerpoint/2010/main" val="1771143164"/>
+      </p:ext>
+    </p:extLst>
+  </p:cSld>
+  <p:clrMapOvr>
+    <a:masterClrMapping/>
+  </p:clrMapOvr>
+</p:sld>
+</file>
+
+<file path=ppt/slides/slide4.xml><?xml version="1.0" encoding="utf-8"?>
+<p:sld xmlns:a="http://schemas.openxmlformats.org/drawingml/2006/main" xmlns:r="http://schemas.openxmlformats.org/officeDocument/2006/relationships" xmlns:p="http://schemas.openxmlformats.org/presentationml/2006/main">
+  <p:cSld>
+    <p:spTree>
+      <p:nvGrpSpPr>
+        <p:cNvPr id="1" name=""/>
+        <p:cNvGrpSpPr/>
+        <p:nvPr/>
+      </p:nvGrpSpPr>
+      <p:grpSpPr>
+        <a:xfrm>
+          <a:off x="0" y="0"/>
+          <a:ext cx="0" cy="0"/>
+          <a:chOff x="0" y="0"/>
+          <a:chExt cx="0" cy="0"/>
+        </a:xfrm>
+      </p:grpSpPr>
+      <p:sp>
+        <p:nvSpPr>
+          <p:cNvPr id="2" name="Title 1">
+            <a:extLst>
+              <a:ext uri="{FF2B5EF4-FFF2-40B4-BE49-F238E27FC236}">
+                <a16:creationId xmlns:a16="http://schemas.microsoft.com/office/drawing/2014/main" id="{90A6CF99-F348-7DA0-384F-6A0947F2671F}"/>
+              </a:ext>
+            </a:extLst>
+          </p:cNvPr>
+          <p:cNvSpPr>
+            <a:spLocks noGrp="1"/>
+          </p:cNvSpPr>
+          <p:nvPr>
+            <p:ph type="title"/>
+          </p:nvPr>
+        </p:nvSpPr>
+        <p:spPr>
+          <a:xfrm>
+            <a:off x="838200" y="188146"/>
+            <a:ext cx="10515600" cy="667262"/>
+          </a:xfrm>
+        </p:spPr>
+        <p:txBody>
+          <a:bodyPr>
+            <a:normAutofit/>
+          </a:bodyPr>
+          <a:lstStyle/>
+          <a:p>
+            <a:pPr algn="ctr"/>
+            <a:r>
+              <a:rPr lang="en-NZ" sz="3600" dirty="0"/>
+              <a:t>Initialize a </a:t>
+            </a:r>
+            <a:r>
+              <a:rPr lang="en-NZ" sz="3600" dirty="0" err="1"/>
+              <a:t>SpringBoot</a:t>
+            </a:r>
+            <a:r>
+              <a:rPr lang="en-NZ" sz="3600" dirty="0"/>
+              <a:t> project </a:t>
+            </a:r>
+            <a:r>
+              <a:rPr lang="en-US" altLang="zh-CN" sz="3600" dirty="0"/>
+              <a:t>Successfully</a:t>
+            </a:r>
+            <a:endParaRPr lang="en-NZ" sz="3600" dirty="0"/>
+          </a:p>
+        </p:txBody>
+      </p:sp>
+      <p:pic>
+        <p:nvPicPr>
+          <p:cNvPr id="13" name="Content Placeholder 12">
+            <a:extLst>
+              <a:ext uri="{FF2B5EF4-FFF2-40B4-BE49-F238E27FC236}">
+                <a16:creationId xmlns:a16="http://schemas.microsoft.com/office/drawing/2014/main" id="{A2BADAF2-7446-94EF-5DF9-6E558000FDF0}"/>
+              </a:ext>
+            </a:extLst>
+          </p:cNvPr>
+          <p:cNvPicPr>
+            <a:picLocks noGrp="1" noChangeAspect="1"/>
+          </p:cNvPicPr>
+          <p:nvPr>
+            <p:ph idx="1"/>
+          </p:nvPr>
+        </p:nvPicPr>
+        <p:blipFill>
+          <a:blip r:embed="rId2"/>
+          <a:stretch>
+            <a:fillRect/>
+          </a:stretch>
+        </p:blipFill>
+        <p:spPr>
+          <a:xfrm>
+            <a:off x="838199" y="855407"/>
+            <a:ext cx="10515599" cy="2371603"/>
+          </a:xfrm>
+          <a:prstGeom prst="rect">
+            <a:avLst/>
+          </a:prstGeom>
+        </p:spPr>
+      </p:pic>
+      <p:pic>
+        <p:nvPicPr>
+          <p:cNvPr id="21" name="Picture 20">
+            <a:extLst>
+              <a:ext uri="{FF2B5EF4-FFF2-40B4-BE49-F238E27FC236}">
+                <a16:creationId xmlns:a16="http://schemas.microsoft.com/office/drawing/2014/main" id="{37FBC05B-6415-2857-A10E-3563C9AD43EA}"/>
+              </a:ext>
+            </a:extLst>
+          </p:cNvPr>
+          <p:cNvPicPr>
+            <a:picLocks noChangeAspect="1"/>
+          </p:cNvPicPr>
+          <p:nvPr/>
+        </p:nvPicPr>
+        <p:blipFill>
+          <a:blip r:embed="rId3"/>
+          <a:stretch>
+            <a:fillRect/>
+          </a:stretch>
+        </p:blipFill>
+        <p:spPr>
+          <a:xfrm>
+            <a:off x="5625920" y="3210975"/>
+            <a:ext cx="5727878" cy="1877000"/>
+          </a:xfrm>
+          <a:prstGeom prst="rect">
+            <a:avLst/>
+          </a:prstGeom>
+        </p:spPr>
+      </p:pic>
+      <p:pic>
+        <p:nvPicPr>
+          <p:cNvPr id="23" name="Picture 22">
+            <a:extLst>
+              <a:ext uri="{FF2B5EF4-FFF2-40B4-BE49-F238E27FC236}">
+                <a16:creationId xmlns:a16="http://schemas.microsoft.com/office/drawing/2014/main" id="{384250F8-6623-1C05-A9D9-5C0F33D3E34C}"/>
+              </a:ext>
+            </a:extLst>
+          </p:cNvPr>
+          <p:cNvPicPr>
+            <a:picLocks noChangeAspect="1"/>
+          </p:cNvPicPr>
+          <p:nvPr/>
+        </p:nvPicPr>
+        <p:blipFill>
+          <a:blip r:embed="rId4"/>
+          <a:stretch>
+            <a:fillRect/>
+          </a:stretch>
+        </p:blipFill>
+        <p:spPr>
+          <a:xfrm>
+            <a:off x="838197" y="3227010"/>
+            <a:ext cx="4787723" cy="1873883"/>
+          </a:xfrm>
+          <a:prstGeom prst="rect">
+            <a:avLst/>
+          </a:prstGeom>
+        </p:spPr>
+      </p:pic>
+      <mc:AlternateContent xmlns:mc="http://schemas.openxmlformats.org/markup-compatibility/2006" xmlns:p14="http://schemas.microsoft.com/office/powerpoint/2010/main">
+        <mc:Choice Requires="p14">
+          <p:contentPart p14:bwMode="auto" r:id="rId5">
+            <p14:nvContentPartPr>
+              <p14:cNvPr id="28" name="Ink 27">
+                <a:extLst>
+                  <a:ext uri="{FF2B5EF4-FFF2-40B4-BE49-F238E27FC236}">
+                    <a16:creationId xmlns:a16="http://schemas.microsoft.com/office/drawing/2014/main" id="{874D4C85-F632-A653-7D0A-6127365D6EB4}"/>
+                  </a:ext>
+                </a:extLst>
+              </p14:cNvPr>
+              <p14:cNvContentPartPr/>
+              <p14:nvPr/>
+            </p14:nvContentPartPr>
+            <p14:xfrm>
+              <a:off x="2253681" y="3564871"/>
+              <a:ext cx="1065960" cy="225360"/>
+            </p14:xfrm>
+          </p:contentPart>
+        </mc:Choice>
+        <mc:Fallback xmlns="">
+          <p:pic>
+            <p:nvPicPr>
+              <p:cNvPr id="28" name="Ink 27">
+                <a:extLst>
+                  <a:ext uri="{FF2B5EF4-FFF2-40B4-BE49-F238E27FC236}">
+                    <a16:creationId xmlns:a16="http://schemas.microsoft.com/office/drawing/2014/main" id="{874D4C85-F632-A653-7D0A-6127365D6EB4}"/>
+                  </a:ext>
+                </a:extLst>
+              </p:cNvPr>
+              <p:cNvPicPr/>
+              <p:nvPr/>
+            </p:nvPicPr>
+            <p:blipFill>
+              <a:blip r:embed="rId6"/>
+              <a:stretch>
+                <a:fillRect/>
+              </a:stretch>
+            </p:blipFill>
+            <p:spPr>
+              <a:xfrm>
+                <a:off x="2247561" y="3558751"/>
+                <a:ext cx="1078200" cy="237600"/>
+              </a:xfrm>
+              <a:prstGeom prst="rect">
+                <a:avLst/>
+              </a:prstGeom>
+            </p:spPr>
+          </p:pic>
+        </mc:Fallback>
+      </mc:AlternateContent>
+      <mc:AlternateContent xmlns:mc="http://schemas.openxmlformats.org/markup-compatibility/2006" xmlns:p14="http://schemas.microsoft.com/office/powerpoint/2010/main">
+        <mc:Choice Requires="p14">
+          <p:contentPart p14:bwMode="auto" r:id="rId7">
+            <p14:nvContentPartPr>
+              <p14:cNvPr id="30" name="Ink 29">
+                <a:extLst>
+                  <a:ext uri="{FF2B5EF4-FFF2-40B4-BE49-F238E27FC236}">
+                    <a16:creationId xmlns:a16="http://schemas.microsoft.com/office/drawing/2014/main" id="{EE743A3B-E65B-BB0A-2F78-723CD4C4B64C}"/>
+                  </a:ext>
+                </a:extLst>
+              </p14:cNvPr>
+              <p14:cNvContentPartPr/>
+              <p14:nvPr/>
+            </p14:nvContentPartPr>
+            <p14:xfrm>
+              <a:off x="2251881" y="4523191"/>
+              <a:ext cx="1024560" cy="257760"/>
+            </p14:xfrm>
+          </p:contentPart>
+        </mc:Choice>
+        <mc:Fallback xmlns="">
+          <p:pic>
+            <p:nvPicPr>
+              <p:cNvPr id="30" name="Ink 29">
+                <a:extLst>
+                  <a:ext uri="{FF2B5EF4-FFF2-40B4-BE49-F238E27FC236}">
+                    <a16:creationId xmlns:a16="http://schemas.microsoft.com/office/drawing/2014/main" id="{EE743A3B-E65B-BB0A-2F78-723CD4C4B64C}"/>
+                  </a:ext>
+                </a:extLst>
+              </p:cNvPr>
+              <p:cNvPicPr/>
+              <p:nvPr/>
+            </p:nvPicPr>
+            <p:blipFill>
+              <a:blip r:embed="rId8"/>
+              <a:stretch>
+                <a:fillRect/>
+              </a:stretch>
+            </p:blipFill>
+            <p:spPr>
+              <a:xfrm>
+                <a:off x="2245761" y="4517071"/>
+                <a:ext cx="1036800" cy="270000"/>
+              </a:xfrm>
+              <a:prstGeom prst="rect">
+                <a:avLst/>
+              </a:prstGeom>
+            </p:spPr>
+          </p:pic>
+        </mc:Fallback>
+      </mc:AlternateContent>
+      <mc:AlternateContent xmlns:mc="http://schemas.openxmlformats.org/markup-compatibility/2006" xmlns:p14="http://schemas.microsoft.com/office/powerpoint/2010/main">
+        <mc:Choice Requires="p14">
+          <p:contentPart p14:bwMode="auto" r:id="rId9">
+            <p14:nvContentPartPr>
+              <p14:cNvPr id="32" name="Ink 31">
+                <a:extLst>
+                  <a:ext uri="{FF2B5EF4-FFF2-40B4-BE49-F238E27FC236}">
+                    <a16:creationId xmlns:a16="http://schemas.microsoft.com/office/drawing/2014/main" id="{A622186E-F2AC-2614-BF7F-227A6AF915F7}"/>
+                  </a:ext>
+                </a:extLst>
+              </p14:cNvPr>
+              <p14:cNvContentPartPr/>
+              <p14:nvPr/>
+            </p14:nvContentPartPr>
+            <p14:xfrm>
+              <a:off x="7358841" y="3716431"/>
+              <a:ext cx="1230480" cy="287640"/>
+            </p14:xfrm>
+          </p:contentPart>
+        </mc:Choice>
+        <mc:Fallback xmlns="">
+          <p:pic>
+            <p:nvPicPr>
+              <p:cNvPr id="32" name="Ink 31">
+                <a:extLst>
+                  <a:ext uri="{FF2B5EF4-FFF2-40B4-BE49-F238E27FC236}">
+                    <a16:creationId xmlns:a16="http://schemas.microsoft.com/office/drawing/2014/main" id="{A622186E-F2AC-2614-BF7F-227A6AF915F7}"/>
+                  </a:ext>
+                </a:extLst>
+              </p:cNvPr>
+              <p:cNvPicPr/>
+              <p:nvPr/>
+            </p:nvPicPr>
+            <p:blipFill>
+              <a:blip r:embed="rId10"/>
+              <a:stretch>
+                <a:fillRect/>
+              </a:stretch>
+            </p:blipFill>
+            <p:spPr>
+              <a:xfrm>
+                <a:off x="7352721" y="3710311"/>
+                <a:ext cx="1242720" cy="299880"/>
+              </a:xfrm>
+              <a:prstGeom prst="rect">
+                <a:avLst/>
+              </a:prstGeom>
+            </p:spPr>
+          </p:pic>
+        </mc:Fallback>
+      </mc:AlternateContent>
+      <mc:AlternateContent xmlns:mc="http://schemas.openxmlformats.org/markup-compatibility/2006" xmlns:p14="http://schemas.microsoft.com/office/powerpoint/2010/main">
+        <mc:Choice Requires="p14">
+          <p:contentPart p14:bwMode="auto" r:id="rId11">
+            <p14:nvContentPartPr>
+              <p14:cNvPr id="33" name="Ink 32">
+                <a:extLst>
+                  <a:ext uri="{FF2B5EF4-FFF2-40B4-BE49-F238E27FC236}">
+                    <a16:creationId xmlns:a16="http://schemas.microsoft.com/office/drawing/2014/main" id="{A5583313-0294-D693-7B87-A0B0645B200D}"/>
+                  </a:ext>
+                </a:extLst>
+              </p14:cNvPr>
+              <p14:cNvContentPartPr/>
+              <p14:nvPr/>
+            </p14:nvContentPartPr>
+            <p14:xfrm>
+              <a:off x="7342281" y="4619671"/>
+              <a:ext cx="1351080" cy="295560"/>
+            </p14:xfrm>
+          </p:contentPart>
+        </mc:Choice>
+        <mc:Fallback xmlns="">
+          <p:pic>
+            <p:nvPicPr>
+              <p:cNvPr id="33" name="Ink 32">
+                <a:extLst>
+                  <a:ext uri="{FF2B5EF4-FFF2-40B4-BE49-F238E27FC236}">
+                    <a16:creationId xmlns:a16="http://schemas.microsoft.com/office/drawing/2014/main" id="{A5583313-0294-D693-7B87-A0B0645B200D}"/>
+                  </a:ext>
+                </a:extLst>
+              </p:cNvPr>
+              <p:cNvPicPr/>
+              <p:nvPr/>
+            </p:nvPicPr>
+            <p:blipFill>
+              <a:blip r:embed="rId12"/>
+              <a:stretch>
+                <a:fillRect/>
+              </a:stretch>
+            </p:blipFill>
+            <p:spPr>
+              <a:xfrm>
+                <a:off x="7336161" y="4613551"/>
+                <a:ext cx="1363320" cy="307800"/>
+              </a:xfrm>
+              <a:prstGeom prst="rect">
+                <a:avLst/>
+              </a:prstGeom>
+            </p:spPr>
+          </p:pic>
+        </mc:Fallback>
+      </mc:AlternateContent>
+      <mc:AlternateContent xmlns:mc="http://schemas.openxmlformats.org/markup-compatibility/2006" xmlns:p14="http://schemas.microsoft.com/office/powerpoint/2010/main">
+        <mc:Choice Requires="p14">
+          <p:contentPart p14:bwMode="auto" r:id="rId13">
+            <p14:nvContentPartPr>
+              <p14:cNvPr id="35" name="Ink 34">
+                <a:extLst>
+                  <a:ext uri="{FF2B5EF4-FFF2-40B4-BE49-F238E27FC236}">
+                    <a16:creationId xmlns:a16="http://schemas.microsoft.com/office/drawing/2014/main" id="{24A6C879-EEBC-1197-1771-30FA3E211265}"/>
+                  </a:ext>
+                </a:extLst>
+              </p14:cNvPr>
+              <p14:cNvContentPartPr/>
+              <p14:nvPr/>
+            </p14:nvContentPartPr>
+            <p14:xfrm>
+              <a:off x="2820321" y="1900231"/>
+              <a:ext cx="1178640" cy="267480"/>
+            </p14:xfrm>
+          </p:contentPart>
+        </mc:Choice>
+        <mc:Fallback xmlns="">
+          <p:pic>
+            <p:nvPicPr>
+              <p:cNvPr id="35" name="Ink 34">
+                <a:extLst>
+                  <a:ext uri="{FF2B5EF4-FFF2-40B4-BE49-F238E27FC236}">
+                    <a16:creationId xmlns:a16="http://schemas.microsoft.com/office/drawing/2014/main" id="{24A6C879-EEBC-1197-1771-30FA3E211265}"/>
+                  </a:ext>
+                </a:extLst>
+              </p:cNvPr>
+              <p:cNvPicPr/>
+              <p:nvPr/>
+            </p:nvPicPr>
+            <p:blipFill>
+              <a:blip r:embed="rId14"/>
+              <a:stretch>
+                <a:fillRect/>
+              </a:stretch>
+            </p:blipFill>
+            <p:spPr>
+              <a:xfrm>
+                <a:off x="2814201" y="1894111"/>
+                <a:ext cx="1190880" cy="279720"/>
+              </a:xfrm>
+              <a:prstGeom prst="rect">
+                <a:avLst/>
+              </a:prstGeom>
+            </p:spPr>
+          </p:pic>
+        </mc:Fallback>
+      </mc:AlternateContent>
+      <p:sp>
+        <p:nvSpPr>
+          <p:cNvPr id="37" name="TextBox 36">
+            <a:extLst>
+              <a:ext uri="{FF2B5EF4-FFF2-40B4-BE49-F238E27FC236}">
+                <a16:creationId xmlns:a16="http://schemas.microsoft.com/office/drawing/2014/main" id="{CEC26ED3-79CF-944B-CBDA-84A0C905EF84}"/>
+              </a:ext>
+            </a:extLst>
+          </p:cNvPr>
+          <p:cNvSpPr txBox="1"/>
+          <p:nvPr/>
+        </p:nvSpPr>
+        <p:spPr>
+          <a:xfrm>
+            <a:off x="4203134" y="2041528"/>
+            <a:ext cx="2315497" cy="369332"/>
+          </a:xfrm>
+          <a:prstGeom prst="rect">
+            <a:avLst/>
+          </a:prstGeom>
+          <a:noFill/>
+        </p:spPr>
+        <p:txBody>
+          <a:bodyPr wrap="square" rtlCol="0">
+            <a:spAutoFit/>
+          </a:bodyPr>
+          <a:lstStyle/>
+          <a:p>
+            <a:r>
+              <a:rPr lang="en-NZ" dirty="0">
+                <a:solidFill>
+                  <a:srgbClr val="FF0000"/>
+                </a:solidFill>
+              </a:rPr>
+              <a:t>4.1.1 version</a:t>
+            </a:r>
+          </a:p>
+        </p:txBody>
+      </p:sp>
+      <p:pic>
+        <p:nvPicPr>
+          <p:cNvPr id="39" name="Picture 38">
+            <a:extLst>
+              <a:ext uri="{FF2B5EF4-FFF2-40B4-BE49-F238E27FC236}">
+                <a16:creationId xmlns:a16="http://schemas.microsoft.com/office/drawing/2014/main" id="{60D2D420-5F65-B762-ED33-C00C494B3A23}"/>
+              </a:ext>
+            </a:extLst>
+          </p:cNvPr>
+          <p:cNvPicPr>
+            <a:picLocks noChangeAspect="1"/>
+          </p:cNvPicPr>
+          <p:nvPr/>
+        </p:nvPicPr>
+        <p:blipFill>
+          <a:blip r:embed="rId15"/>
+          <a:srcRect b="27347"/>
+          <a:stretch>
+            <a:fillRect/>
+          </a:stretch>
+        </p:blipFill>
+        <p:spPr>
+          <a:xfrm>
+            <a:off x="838197" y="5100893"/>
+            <a:ext cx="3792797" cy="1059299"/>
+          </a:xfrm>
+          <a:prstGeom prst="rect">
+            <a:avLst/>
+          </a:prstGeom>
+        </p:spPr>
+      </p:pic>
+      <p:pic>
+        <p:nvPicPr>
+          <p:cNvPr id="43" name="Picture 42">
+            <a:extLst>
+              <a:ext uri="{FF2B5EF4-FFF2-40B4-BE49-F238E27FC236}">
+                <a16:creationId xmlns:a16="http://schemas.microsoft.com/office/drawing/2014/main" id="{B4A7B234-0ADE-1276-8E15-DE439039B45B}"/>
+              </a:ext>
+            </a:extLst>
+          </p:cNvPr>
+          <p:cNvPicPr>
+            <a:picLocks noChangeAspect="1"/>
+          </p:cNvPicPr>
+          <p:nvPr/>
+        </p:nvPicPr>
+        <p:blipFill>
+          <a:blip r:embed="rId16"/>
+          <a:stretch>
+            <a:fillRect/>
+          </a:stretch>
+        </p:blipFill>
+        <p:spPr>
+          <a:xfrm>
+            <a:off x="4630994" y="5126257"/>
+            <a:ext cx="6722804" cy="1021017"/>
+          </a:xfrm>
+          <a:prstGeom prst="rect">
+            <a:avLst/>
+          </a:prstGeom>
+        </p:spPr>
+      </p:pic>
+      <p:sp>
+        <p:nvSpPr>
+          <p:cNvPr id="44" name="TextBox 43">
+            <a:extLst>
+              <a:ext uri="{FF2B5EF4-FFF2-40B4-BE49-F238E27FC236}">
+                <a16:creationId xmlns:a16="http://schemas.microsoft.com/office/drawing/2014/main" id="{38B70EBF-7904-DF82-1840-2314F8F7E3F6}"/>
+              </a:ext>
+            </a:extLst>
+          </p:cNvPr>
+          <p:cNvSpPr txBox="1"/>
+          <p:nvPr/>
+        </p:nvSpPr>
+        <p:spPr>
+          <a:xfrm>
+            <a:off x="8693361" y="2137223"/>
+            <a:ext cx="1637071" cy="461665"/>
+          </a:xfrm>
+          <a:prstGeom prst="rect">
+            <a:avLst/>
+          </a:prstGeom>
+          <a:noFill/>
+        </p:spPr>
+        <p:txBody>
+          <a:bodyPr wrap="square" rtlCol="0">
+            <a:spAutoFit/>
+          </a:bodyPr>
+          <a:lstStyle/>
+          <a:p>
+            <a:r>
+              <a:rPr lang="en-NZ" sz="2400" dirty="0">
+                <a:solidFill>
+                  <a:srgbClr val="FF0000"/>
+                </a:solidFill>
+              </a:rPr>
+              <a:t>pom.xml</a:t>
+            </a:r>
+          </a:p>
+        </p:txBody>
+      </p:sp>
+    </p:spTree>
+    <p:extLst>
+      <p:ext uri="{BB962C8B-B14F-4D97-AF65-F5344CB8AC3E}">
+        <p14:creationId xmlns:p14="http://schemas.microsoft.com/office/powerpoint/2010/main" val="3499815128"/>
+      </p:ext>
+    </p:extLst>
+  </p:cSld>
+  <p:clrMapOvr>
+    <a:masterClrMapping/>
+  </p:clrMapOvr>
+</p:sld>
+</file>
+
+<file path=ppt/slides/slide5.xml><?xml version="1.0" encoding="utf-8"?>
+<p:sld xmlns:a="http://schemas.openxmlformats.org/drawingml/2006/main" xmlns:r="http://schemas.openxmlformats.org/officeDocument/2006/relationships" xmlns:p="http://schemas.openxmlformats.org/presentationml/2006/main">
+  <p:cSld>
+    <p:spTree>
+      <p:nvGrpSpPr>
+        <p:cNvPr id="1" name=""/>
+        <p:cNvGrpSpPr/>
+        <p:nvPr/>
+      </p:nvGrpSpPr>
+      <p:grpSpPr>
+        <a:xfrm>
+          <a:off x="0" y="0"/>
+          <a:ext cx="0" cy="0"/>
+          <a:chOff x="0" y="0"/>
+          <a:chExt cx="0" cy="0"/>
+        </a:xfrm>
+      </p:grpSpPr>
+      <p:sp>
+        <p:nvSpPr>
+          <p:cNvPr id="2" name="Title 1">
+            <a:extLst>
+              <a:ext uri="{FF2B5EF4-FFF2-40B4-BE49-F238E27FC236}">
+                <a16:creationId xmlns:a16="http://schemas.microsoft.com/office/drawing/2014/main" id="{D1EEC0D4-79BF-9C01-E6B0-9C7919A25A72}"/>
+              </a:ext>
+            </a:extLst>
+          </p:cNvPr>
+          <p:cNvSpPr>
+            <a:spLocks noGrp="1"/>
+          </p:cNvSpPr>
+          <p:nvPr>
+            <p:ph type="title"/>
+          </p:nvPr>
+        </p:nvSpPr>
+        <p:spPr>
+          <a:xfrm>
+            <a:off x="838200" y="173396"/>
+            <a:ext cx="10515600" cy="726256"/>
+          </a:xfrm>
+        </p:spPr>
+        <p:txBody>
+          <a:bodyPr>
+            <a:normAutofit/>
+          </a:bodyPr>
+          <a:lstStyle/>
+          <a:p>
+            <a:pPr algn="ctr"/>
+            <a:r>
+              <a:rPr lang="en-US" sz="4000" dirty="0"/>
+              <a:t>Vue.js: </a:t>
+            </a:r>
+            <a:r>
+              <a:rPr lang="en-US" sz="4000" dirty="0" err="1"/>
+              <a:t>Fro</a:t>
+            </a:r>
+            <a:r>
+              <a:rPr lang="en-NZ" sz="4000" dirty="0" err="1"/>
+              <a:t>ntend</a:t>
+            </a:r>
+            <a:r>
+              <a:rPr lang="en-US" sz="4000" dirty="0"/>
+              <a:t> of the project</a:t>
+            </a:r>
+            <a:endParaRPr lang="en-NZ" sz="4000" dirty="0"/>
+          </a:p>
+        </p:txBody>
+      </p:sp>
+      <p:pic>
+        <p:nvPicPr>
+          <p:cNvPr id="5" name="Content Placeholder 4">
+            <a:extLst>
+              <a:ext uri="{FF2B5EF4-FFF2-40B4-BE49-F238E27FC236}">
+                <a16:creationId xmlns:a16="http://schemas.microsoft.com/office/drawing/2014/main" id="{E97531A4-6C4C-34CD-21B1-4EBA373B9715}"/>
+              </a:ext>
+            </a:extLst>
+          </p:cNvPr>
+          <p:cNvPicPr>
+            <a:picLocks noGrp="1" noChangeAspect="1"/>
+          </p:cNvPicPr>
+          <p:nvPr>
+            <p:ph idx="1"/>
+          </p:nvPr>
+        </p:nvPicPr>
+        <p:blipFill>
+          <a:blip r:embed="rId2"/>
+          <a:stretch>
+            <a:fillRect/>
+          </a:stretch>
+        </p:blipFill>
+        <p:spPr>
+          <a:xfrm>
+            <a:off x="320777" y="899652"/>
+            <a:ext cx="11550446" cy="1715291"/>
+          </a:xfrm>
+          <a:prstGeom prst="rect">
+            <a:avLst/>
+          </a:prstGeom>
+        </p:spPr>
+      </p:pic>
+      <p:pic>
+        <p:nvPicPr>
+          <p:cNvPr id="10" name="Picture 9">
+            <a:extLst>
+              <a:ext uri="{FF2B5EF4-FFF2-40B4-BE49-F238E27FC236}">
+                <a16:creationId xmlns:a16="http://schemas.microsoft.com/office/drawing/2014/main" id="{271646E4-AC47-E184-652D-87E4EDAF3E70}"/>
+              </a:ext>
+            </a:extLst>
+          </p:cNvPr>
+          <p:cNvPicPr>
+            <a:picLocks noChangeAspect="1"/>
+          </p:cNvPicPr>
+          <p:nvPr/>
+        </p:nvPicPr>
+        <p:blipFill>
+          <a:blip r:embed="rId3"/>
+          <a:stretch>
+            <a:fillRect/>
+          </a:stretch>
+        </p:blipFill>
+        <p:spPr>
+          <a:xfrm>
+            <a:off x="320777" y="3091422"/>
+            <a:ext cx="11550446" cy="3593182"/>
+          </a:xfrm>
+          <a:prstGeom prst="rect">
+            <a:avLst/>
+          </a:prstGeom>
+        </p:spPr>
+      </p:pic>
+      <p:pic>
+        <p:nvPicPr>
+          <p:cNvPr id="12" name="Picture 11">
+            <a:extLst>
+              <a:ext uri="{FF2B5EF4-FFF2-40B4-BE49-F238E27FC236}">
+                <a16:creationId xmlns:a16="http://schemas.microsoft.com/office/drawing/2014/main" id="{C1F31EAA-1F49-EB82-AD0A-D56FE367E9BC}"/>
+              </a:ext>
+            </a:extLst>
+          </p:cNvPr>
+          <p:cNvPicPr>
+            <a:picLocks noChangeAspect="1"/>
+          </p:cNvPicPr>
+          <p:nvPr/>
+        </p:nvPicPr>
+        <p:blipFill>
+          <a:blip r:embed="rId4"/>
+          <a:stretch>
+            <a:fillRect/>
+          </a:stretch>
+        </p:blipFill>
+        <p:spPr>
+          <a:xfrm>
+            <a:off x="6748692" y="3428999"/>
+            <a:ext cx="4460081" cy="3209711"/>
+          </a:xfrm>
+          <a:prstGeom prst="rect">
+            <a:avLst/>
+          </a:prstGeom>
+        </p:spPr>
+      </p:pic>
+      <mc:AlternateContent xmlns:mc="http://schemas.openxmlformats.org/markup-compatibility/2006" xmlns:p14="http://schemas.microsoft.com/office/powerpoint/2010/main">
+        <mc:Choice Requires="p14">
+          <p:contentPart p14:bwMode="auto" r:id="rId5">
+            <p14:nvContentPartPr>
+              <p14:cNvPr id="13" name="Ink 12">
+                <a:extLst>
+                  <a:ext uri="{FF2B5EF4-FFF2-40B4-BE49-F238E27FC236}">
+                    <a16:creationId xmlns:a16="http://schemas.microsoft.com/office/drawing/2014/main" id="{FB57EE14-0B43-CAEE-5717-4F5B2FC4ADD2}"/>
+                  </a:ext>
+                </a:extLst>
+              </p14:cNvPr>
+              <p14:cNvContentPartPr/>
+              <p14:nvPr/>
+            </p14:nvContentPartPr>
+            <p14:xfrm>
+              <a:off x="6885081" y="4864471"/>
+              <a:ext cx="1836360" cy="682200"/>
+            </p14:xfrm>
+          </p:contentPart>
+        </mc:Choice>
+        <mc:Fallback xmlns="">
+          <p:pic>
+            <p:nvPicPr>
+              <p:cNvPr id="13" name="Ink 12">
+                <a:extLst>
+                  <a:ext uri="{FF2B5EF4-FFF2-40B4-BE49-F238E27FC236}">
+                    <a16:creationId xmlns:a16="http://schemas.microsoft.com/office/drawing/2014/main" id="{FB57EE14-0B43-CAEE-5717-4F5B2FC4ADD2}"/>
+                  </a:ext>
+                </a:extLst>
+              </p:cNvPr>
+              <p:cNvPicPr/>
+              <p:nvPr/>
+            </p:nvPicPr>
+            <p:blipFill>
+              <a:blip r:embed="rId6"/>
+              <a:stretch>
+                <a:fillRect/>
+              </a:stretch>
+            </p:blipFill>
+            <p:spPr>
+              <a:xfrm>
+                <a:off x="6878961" y="4858351"/>
+                <a:ext cx="1848600" cy="694440"/>
+              </a:xfrm>
+              <a:prstGeom prst="rect">
+                <a:avLst/>
+              </a:prstGeom>
+            </p:spPr>
+          </p:pic>
+        </mc:Fallback>
+      </mc:AlternateContent>
+      <p:sp>
+        <p:nvSpPr>
+          <p:cNvPr id="14" name="TextBox 13">
+            <a:extLst>
+              <a:ext uri="{FF2B5EF4-FFF2-40B4-BE49-F238E27FC236}">
+                <a16:creationId xmlns:a16="http://schemas.microsoft.com/office/drawing/2014/main" id="{A8F476FF-584C-4CE5-29A6-33EC7F241970}"/>
+              </a:ext>
+            </a:extLst>
+          </p:cNvPr>
+          <p:cNvSpPr txBox="1"/>
+          <p:nvPr/>
+        </p:nvSpPr>
+        <p:spPr>
+          <a:xfrm>
+            <a:off x="8721441" y="5043948"/>
+            <a:ext cx="1602430" cy="400110"/>
+          </a:xfrm>
+          <a:prstGeom prst="rect">
+            <a:avLst/>
+          </a:prstGeom>
+          <a:noFill/>
+        </p:spPr>
+        <p:txBody>
+          <a:bodyPr wrap="square" rtlCol="0">
+            <a:spAutoFit/>
+          </a:bodyPr>
+          <a:lstStyle/>
+          <a:p>
+            <a:r>
+              <a:rPr lang="zh-CN" altLang="en-US" sz="2000" dirty="0">
+                <a:solidFill>
+                  <a:srgbClr val="FF0000"/>
+                </a:solidFill>
+              </a:rPr>
+              <a:t>前后端分离</a:t>
+            </a:r>
+            <a:endParaRPr lang="en-NZ" sz="2000" dirty="0">
+              <a:solidFill>
+                <a:srgbClr val="FF0000"/>
+              </a:solidFill>
+            </a:endParaRPr>
+          </a:p>
+        </p:txBody>
+      </p:sp>
+      <mc:AlternateContent xmlns:mc="http://schemas.openxmlformats.org/markup-compatibility/2006" xmlns:p14="http://schemas.microsoft.com/office/powerpoint/2010/main">
+        <mc:Choice Requires="p14">
+          <p:contentPart p14:bwMode="auto" r:id="rId7">
+            <p14:nvContentPartPr>
+              <p14:cNvPr id="15" name="Ink 14">
+                <a:extLst>
+                  <a:ext uri="{FF2B5EF4-FFF2-40B4-BE49-F238E27FC236}">
+                    <a16:creationId xmlns:a16="http://schemas.microsoft.com/office/drawing/2014/main" id="{D7BF0CEB-3AD3-62A6-A79A-8AFB88A7B4ED}"/>
+                  </a:ext>
+                </a:extLst>
+              </p14:cNvPr>
+              <p14:cNvContentPartPr/>
+              <p14:nvPr/>
+            </p14:nvContentPartPr>
+            <p14:xfrm>
+              <a:off x="3642201" y="1869271"/>
+              <a:ext cx="296280" cy="257400"/>
+            </p14:xfrm>
+          </p:contentPart>
+        </mc:Choice>
+        <mc:Fallback xmlns="">
+          <p:pic>
+            <p:nvPicPr>
+              <p:cNvPr id="15" name="Ink 14">
+                <a:extLst>
+                  <a:ext uri="{FF2B5EF4-FFF2-40B4-BE49-F238E27FC236}">
+                    <a16:creationId xmlns:a16="http://schemas.microsoft.com/office/drawing/2014/main" id="{D7BF0CEB-3AD3-62A6-A79A-8AFB88A7B4ED}"/>
+                  </a:ext>
+                </a:extLst>
+              </p:cNvPr>
+              <p:cNvPicPr/>
+              <p:nvPr/>
+            </p:nvPicPr>
+            <p:blipFill>
+              <a:blip r:embed="rId8"/>
+              <a:stretch>
+                <a:fillRect/>
+              </a:stretch>
+            </p:blipFill>
+            <p:spPr>
+              <a:xfrm>
+                <a:off x="3636081" y="1863151"/>
+                <a:ext cx="308520" cy="269640"/>
+              </a:xfrm>
+              <a:prstGeom prst="rect">
+                <a:avLst/>
+              </a:prstGeom>
+            </p:spPr>
+          </p:pic>
+        </mc:Fallback>
+      </mc:AlternateContent>
+      <p:sp>
+        <p:nvSpPr>
+          <p:cNvPr id="16" name="TextBox 15">
+            <a:extLst>
+              <a:ext uri="{FF2B5EF4-FFF2-40B4-BE49-F238E27FC236}">
+                <a16:creationId xmlns:a16="http://schemas.microsoft.com/office/drawing/2014/main" id="{A52A5D3E-B51C-1117-3492-212E12DFF625}"/>
+              </a:ext>
+            </a:extLst>
+          </p:cNvPr>
+          <p:cNvSpPr txBox="1"/>
+          <p:nvPr/>
+        </p:nvSpPr>
+        <p:spPr>
+          <a:xfrm>
+            <a:off x="8978732" y="1184406"/>
+            <a:ext cx="2182761" cy="400110"/>
+          </a:xfrm>
+          <a:prstGeom prst="rect">
+            <a:avLst/>
+          </a:prstGeom>
+          <a:noFill/>
+        </p:spPr>
+        <p:txBody>
+          <a:bodyPr wrap="square" rtlCol="0">
+            <a:spAutoFit/>
+          </a:bodyPr>
+          <a:lstStyle/>
+          <a:p>
+            <a:r>
+              <a:rPr lang="zh-CN" altLang="en-US" sz="2000" dirty="0">
+                <a:solidFill>
+                  <a:srgbClr val="FF0000"/>
+                </a:solidFill>
+              </a:rPr>
+              <a:t>建立前端文件夹</a:t>
+            </a:r>
+            <a:endParaRPr lang="en-NZ" sz="2000" dirty="0">
+              <a:solidFill>
+                <a:srgbClr val="FF0000"/>
+              </a:solidFill>
+            </a:endParaRPr>
+          </a:p>
+        </p:txBody>
+      </p:sp>
+      <mc:AlternateContent xmlns:mc="http://schemas.openxmlformats.org/markup-compatibility/2006" xmlns:p14="http://schemas.microsoft.com/office/powerpoint/2010/main">
+        <mc:Choice Requires="p14">
+          <p:contentPart p14:bwMode="auto" r:id="rId9">
+            <p14:nvContentPartPr>
+              <p14:cNvPr id="18" name="Ink 17">
+                <a:extLst>
+                  <a:ext uri="{FF2B5EF4-FFF2-40B4-BE49-F238E27FC236}">
+                    <a16:creationId xmlns:a16="http://schemas.microsoft.com/office/drawing/2014/main" id="{1CF385BE-B30E-07E5-FB81-292505E5A6B9}"/>
+                  </a:ext>
+                </a:extLst>
+              </p14:cNvPr>
+              <p14:cNvContentPartPr/>
+              <p14:nvPr/>
+            </p14:nvContentPartPr>
+            <p14:xfrm>
+              <a:off x="4025601" y="6016831"/>
+              <a:ext cx="442800" cy="44280"/>
+            </p14:xfrm>
+          </p:contentPart>
+        </mc:Choice>
+        <mc:Fallback xmlns="">
+          <p:pic>
+            <p:nvPicPr>
+              <p:cNvPr id="18" name="Ink 17">
+                <a:extLst>
+                  <a:ext uri="{FF2B5EF4-FFF2-40B4-BE49-F238E27FC236}">
+                    <a16:creationId xmlns:a16="http://schemas.microsoft.com/office/drawing/2014/main" id="{1CF385BE-B30E-07E5-FB81-292505E5A6B9}"/>
+                  </a:ext>
+                </a:extLst>
+              </p:cNvPr>
+              <p:cNvPicPr/>
+              <p:nvPr/>
+            </p:nvPicPr>
+            <p:blipFill>
+              <a:blip r:embed="rId10"/>
+              <a:stretch>
+                <a:fillRect/>
+              </a:stretch>
+            </p:blipFill>
+            <p:spPr>
+              <a:xfrm>
+                <a:off x="4019481" y="6010711"/>
+                <a:ext cx="455040" cy="56520"/>
+              </a:xfrm>
+              <a:prstGeom prst="rect">
+                <a:avLst/>
+              </a:prstGeom>
+            </p:spPr>
+          </p:pic>
+        </mc:Fallback>
+      </mc:AlternateContent>
+      <mc:AlternateContent xmlns:mc="http://schemas.openxmlformats.org/markup-compatibility/2006" xmlns:p14="http://schemas.microsoft.com/office/powerpoint/2010/main">
+        <mc:Choice Requires="p14">
+          <p:contentPart p14:bwMode="auto" r:id="rId11">
+            <p14:nvContentPartPr>
+              <p14:cNvPr id="19" name="Ink 18">
+                <a:extLst>
+                  <a:ext uri="{FF2B5EF4-FFF2-40B4-BE49-F238E27FC236}">
+                    <a16:creationId xmlns:a16="http://schemas.microsoft.com/office/drawing/2014/main" id="{04FD6274-DBD6-B40F-C786-A552C9AB09FD}"/>
+                  </a:ext>
+                </a:extLst>
+              </p14:cNvPr>
+              <p14:cNvContentPartPr/>
+              <p14:nvPr/>
+            </p14:nvContentPartPr>
+            <p14:xfrm>
+              <a:off x="3465441" y="5795431"/>
+              <a:ext cx="529920" cy="360"/>
+            </p14:xfrm>
+          </p:contentPart>
+        </mc:Choice>
+        <mc:Fallback xmlns="">
+          <p:pic>
+            <p:nvPicPr>
+              <p:cNvPr id="19" name="Ink 18">
+                <a:extLst>
+                  <a:ext uri="{FF2B5EF4-FFF2-40B4-BE49-F238E27FC236}">
+                    <a16:creationId xmlns:a16="http://schemas.microsoft.com/office/drawing/2014/main" id="{04FD6274-DBD6-B40F-C786-A552C9AB09FD}"/>
+                  </a:ext>
+                </a:extLst>
+              </p:cNvPr>
+              <p:cNvPicPr/>
+              <p:nvPr/>
+            </p:nvPicPr>
+            <p:blipFill>
+              <a:blip r:embed="rId12"/>
+              <a:stretch>
+                <a:fillRect/>
+              </a:stretch>
+            </p:blipFill>
+            <p:spPr>
+              <a:xfrm>
+                <a:off x="3459321" y="5789311"/>
+                <a:ext cx="542160" cy="12600"/>
+              </a:xfrm>
+              <a:prstGeom prst="rect">
+                <a:avLst/>
+              </a:prstGeom>
+            </p:spPr>
+          </p:pic>
+        </mc:Fallback>
+      </mc:AlternateContent>
+      <p:sp>
+        <p:nvSpPr>
+          <p:cNvPr id="20" name="TextBox 19">
+            <a:extLst>
+              <a:ext uri="{FF2B5EF4-FFF2-40B4-BE49-F238E27FC236}">
+                <a16:creationId xmlns:a16="http://schemas.microsoft.com/office/drawing/2014/main" id="{C8CF617F-59C2-ABF3-956A-EC8FD6DF88BE}"/>
+              </a:ext>
+            </a:extLst>
+          </p:cNvPr>
+          <p:cNvSpPr txBox="1"/>
+          <p:nvPr/>
+        </p:nvSpPr>
+        <p:spPr>
+          <a:xfrm>
+            <a:off x="2094357" y="5043948"/>
+            <a:ext cx="4334005" cy="400110"/>
+          </a:xfrm>
+          <a:prstGeom prst="rect">
+            <a:avLst/>
+          </a:prstGeom>
+          <a:noFill/>
+        </p:spPr>
+        <p:txBody>
+          <a:bodyPr wrap="square" rtlCol="0">
+            <a:spAutoFit/>
+          </a:bodyPr>
+          <a:lstStyle/>
+          <a:p>
+            <a:r>
+              <a:rPr lang="zh-CN" altLang="en-US" sz="2000" dirty="0">
+                <a:solidFill>
+                  <a:srgbClr val="FF0000"/>
+                </a:solidFill>
+              </a:rPr>
+              <a:t>前端采用</a:t>
+            </a:r>
+            <a:r>
+              <a:rPr lang="en-NZ" altLang="zh-CN" sz="2000" dirty="0">
+                <a:solidFill>
+                  <a:srgbClr val="FF0000"/>
+                </a:solidFill>
+              </a:rPr>
+              <a:t>8081</a:t>
+            </a:r>
+            <a:r>
+              <a:rPr lang="zh-CN" altLang="en-US" sz="2000" dirty="0">
+                <a:solidFill>
+                  <a:srgbClr val="FF0000"/>
+                </a:solidFill>
+              </a:rPr>
+              <a:t>端口，与后端分开</a:t>
+            </a:r>
+            <a:endParaRPr lang="en-NZ" sz="2000" dirty="0">
+              <a:solidFill>
+                <a:srgbClr val="FF0000"/>
+              </a:solidFill>
+            </a:endParaRPr>
+          </a:p>
+        </p:txBody>
+      </p:sp>
+    </p:spTree>
+    <p:extLst>
+      <p:ext uri="{BB962C8B-B14F-4D97-AF65-F5344CB8AC3E}">
+        <p14:creationId xmlns:p14="http://schemas.microsoft.com/office/powerpoint/2010/main" val="1407791421"/>
+      </p:ext>
+    </p:extLst>
+  </p:cSld>
+  <p:clrMapOvr>
+    <a:masterClrMapping/>
+  </p:clrMapOvr>
+</p:sld>
+</file>
+
+<file path=ppt/slides/slide6.xml><?xml version="1.0" encoding="utf-8"?>
+<p:sld xmlns:a="http://schemas.openxmlformats.org/drawingml/2006/main" xmlns:r="http://schemas.openxmlformats.org/officeDocument/2006/relationships" xmlns:p="http://schemas.openxmlformats.org/presentationml/2006/main">
+  <p:cSld>
+    <p:spTree>
+      <p:nvGrpSpPr>
+        <p:cNvPr id="1" name=""/>
+        <p:cNvGrpSpPr/>
+        <p:nvPr/>
+      </p:nvGrpSpPr>
+      <p:grpSpPr>
+        <a:xfrm>
+          <a:off x="0" y="0"/>
+          <a:ext cx="0" cy="0"/>
+          <a:chOff x="0" y="0"/>
+          <a:chExt cx="0" cy="0"/>
+        </a:xfrm>
+      </p:grpSpPr>
+      <p:sp>
+        <p:nvSpPr>
+          <p:cNvPr id="2" name="Title 1">
+            <a:extLst>
+              <a:ext uri="{FF2B5EF4-FFF2-40B4-BE49-F238E27FC236}">
+                <a16:creationId xmlns:a16="http://schemas.microsoft.com/office/drawing/2014/main" id="{5670C305-4654-94BD-EE2E-86C09E52782B}"/>
+              </a:ext>
+            </a:extLst>
+          </p:cNvPr>
+          <p:cNvSpPr>
+            <a:spLocks noGrp="1"/>
+          </p:cNvSpPr>
+          <p:nvPr>
+            <p:ph type="title"/>
+          </p:nvPr>
+        </p:nvSpPr>
+        <p:spPr/>
+        <p:txBody>
+          <a:bodyPr/>
+          <a:lstStyle/>
+          <a:p>
+            <a:r>
+              <a:rPr lang="en-NZ" dirty="0"/>
+              <a:t>Database design</a:t>
+            </a:r>
+            <a:r>
+              <a:rPr lang="en-US" dirty="0"/>
+              <a:t> (on textbook)</a:t>
+            </a:r>
+            <a:endParaRPr lang="en-NZ" dirty="0"/>
+          </a:p>
+        </p:txBody>
+      </p:sp>
+      <p:sp>
+        <p:nvSpPr>
+          <p:cNvPr id="3" name="Content Placeholder 2">
+            <a:extLst>
+              <a:ext uri="{FF2B5EF4-FFF2-40B4-BE49-F238E27FC236}">
+                <a16:creationId xmlns:a16="http://schemas.microsoft.com/office/drawing/2014/main" id="{FDEA33C9-3620-346D-326D-2A96AA8A0BC8}"/>
+              </a:ext>
+            </a:extLst>
+          </p:cNvPr>
+          <p:cNvSpPr>
+            <a:spLocks noGrp="1"/>
+          </p:cNvSpPr>
+          <p:nvPr>
+            <p:ph idx="1"/>
+          </p:nvPr>
+        </p:nvSpPr>
+        <p:spPr/>
+        <p:txBody>
+          <a:bodyPr/>
+          <a:lstStyle/>
+          <a:p>
+            <a:endParaRPr lang="en-NZ" dirty="0"/>
+          </a:p>
+        </p:txBody>
+      </p:sp>
+    </p:spTree>
+    <p:extLst>
+      <p:ext uri="{BB962C8B-B14F-4D97-AF65-F5344CB8AC3E}">
+        <p14:creationId xmlns:p14="http://schemas.microsoft.com/office/powerpoint/2010/main" val="2099799957"/>
+      </p:ext>
+    </p:extLst>
+  </p:cSld>
+  <p:clrMapOvr>
+    <a:masterClrMapping/>
+  </p:clrMapOvr>
+</p:sld>
+</file>
+
+<file path=ppt/slides/slide7.xml><?xml version="1.0" encoding="utf-8"?>
+<p:sld xmlns:a="http://schemas.openxmlformats.org/drawingml/2006/main" xmlns:r="http://schemas.openxmlformats.org/officeDocument/2006/relationships" xmlns:p="http://schemas.openxmlformats.org/presentationml/2006/main">
+  <p:cSld>
+    <p:spTree>
+      <p:nvGrpSpPr>
+        <p:cNvPr id="1" name=""/>
+        <p:cNvGrpSpPr/>
+        <p:nvPr/>
+      </p:nvGrpSpPr>
+      <p:grpSpPr>
+        <a:xfrm>
+          <a:off x="0" y="0"/>
+          <a:ext cx="0" cy="0"/>
+          <a:chOff x="0" y="0"/>
+          <a:chExt cx="0" cy="0"/>
+        </a:xfrm>
+      </p:grpSpPr>
+      <p:sp>
+        <p:nvSpPr>
+          <p:cNvPr id="2" name="Title 1">
+            <a:extLst>
+              <a:ext uri="{FF2B5EF4-FFF2-40B4-BE49-F238E27FC236}">
+                <a16:creationId xmlns:a16="http://schemas.microsoft.com/office/drawing/2014/main" id="{0AD7D334-6CBE-BA1C-3DFF-A010E6F0D1CD}"/>
+              </a:ext>
+            </a:extLst>
+          </p:cNvPr>
+          <p:cNvSpPr>
+            <a:spLocks noGrp="1"/>
+          </p:cNvSpPr>
+          <p:nvPr>
+            <p:ph type="title"/>
+          </p:nvPr>
+        </p:nvSpPr>
+        <p:spPr/>
+        <p:txBody>
+          <a:bodyPr/>
+          <a:lstStyle/>
+          <a:p>
+            <a:r>
+              <a:rPr lang="en-NZ" dirty="0"/>
+              <a:t>Next </a:t>
+            </a:r>
+            <a:r>
+              <a:rPr lang="en-US" altLang="zh-CN" dirty="0"/>
+              <a:t>Step</a:t>
+            </a:r>
+            <a:endParaRPr lang="en-NZ" dirty="0"/>
+          </a:p>
+        </p:txBody>
+      </p:sp>
+      <p:sp>
+        <p:nvSpPr>
+          <p:cNvPr id="3" name="Content Placeholder 2">
+            <a:extLst>
+              <a:ext uri="{FF2B5EF4-FFF2-40B4-BE49-F238E27FC236}">
+                <a16:creationId xmlns:a16="http://schemas.microsoft.com/office/drawing/2014/main" id="{5E53C692-AB53-195B-C26A-058FEBE85AFD}"/>
+              </a:ext>
+            </a:extLst>
+          </p:cNvPr>
+          <p:cNvSpPr>
+            <a:spLocks noGrp="1"/>
+          </p:cNvSpPr>
+          <p:nvPr>
+            <p:ph idx="1"/>
+          </p:nvPr>
+        </p:nvSpPr>
+        <p:spPr/>
+        <p:txBody>
+          <a:bodyPr/>
+          <a:lstStyle/>
+          <a:p>
+            <a:pPr marL="514350" indent="-514350">
+              <a:buAutoNum type="arabicPeriod"/>
+            </a:pPr>
+            <a:r>
+              <a:rPr lang="en-NZ" dirty="0"/>
+              <a:t>Update table design according to discussion. </a:t>
+            </a:r>
+          </a:p>
+          <a:p>
+            <a:pPr marL="514350" indent="-514350">
+              <a:buAutoNum type="arabicPeriod"/>
+            </a:pPr>
+            <a:r>
+              <a:rPr lang="en-NZ" dirty="0"/>
+              <a:t>Create tables in Eclipse (Refer to </a:t>
+            </a:r>
+            <a:r>
+              <a:rPr lang="en-NZ"/>
+              <a:t>Capstone Project). </a:t>
+            </a:r>
+            <a:endParaRPr lang="en-NZ" dirty="0"/>
+          </a:p>
+        </p:txBody>
+      </p:sp>
+    </p:spTree>
+    <p:extLst>
+      <p:ext uri="{BB962C8B-B14F-4D97-AF65-F5344CB8AC3E}">
+        <p14:creationId xmlns:p14="http://schemas.microsoft.com/office/powerpoint/2010/main" val="246407795"/>
       </p:ext>
     </p:extLst>
   </p:cSld>
@@ -3718,4 +6766,319 @@
     </a:ext>
   </a:extLst>
 </a:theme>
+</file>
+
+<file path=ppt/theme/theme2.xml><?xml version="1.0" encoding="utf-8"?>
+<a:theme xmlns:a="http://schemas.openxmlformats.org/drawingml/2006/main" name="Office Theme">
+  <a:themeElements>
+    <a:clrScheme name="Office">
+      <a:dk1>
+        <a:sysClr val="windowText" lastClr="000000"/>
+      </a:dk1>
+      <a:lt1>
+        <a:sysClr val="window" lastClr="FFFFFF"/>
+      </a:lt1>
+      <a:dk2>
+        <a:srgbClr val="0E2841"/>
+      </a:dk2>
+      <a:lt2>
+        <a:srgbClr val="E8E8E8"/>
+      </a:lt2>
+      <a:accent1>
+        <a:srgbClr val="156082"/>
+      </a:accent1>
+      <a:accent2>
+        <a:srgbClr val="E97132"/>
+      </a:accent2>
+      <a:accent3>
+        <a:srgbClr val="196B24"/>
+      </a:accent3>
+      <a:accent4>
+        <a:srgbClr val="0F9ED5"/>
+      </a:accent4>
+      <a:accent5>
+        <a:srgbClr val="A02B93"/>
+      </a:accent5>
+      <a:accent6>
+        <a:srgbClr val="4EA72E"/>
+      </a:accent6>
+      <a:hlink>
+        <a:srgbClr val="467886"/>
+      </a:hlink>
+      <a:folHlink>
+        <a:srgbClr val="96607D"/>
+      </a:folHlink>
+    </a:clrScheme>
+    <a:fontScheme name="Office">
+      <a:majorFont>
+        <a:latin typeface="Aptos Display" panose="02110004020202020204"/>
+        <a:ea typeface=""/>
+        <a:cs typeface=""/>
+        <a:font script="Jpan" typeface="游ゴシック Light"/>
+        <a:font script="Hang" typeface="맑은 고딕"/>
+        <a:font script="Hans" typeface="等线 Light"/>
+        <a:font script="Hant" typeface="新細明體"/>
+        <a:font script="Arab" typeface="Times New Roman"/>
+        <a:font script="Hebr" typeface="Times New Roman"/>
+        <a:font script="Thai" typeface="Angsana New"/>
+        <a:font script="Ethi" typeface="Nyala"/>
+        <a:font script="Beng" typeface="Vrinda"/>
+        <a:font script="Gujr" typeface="Shruti"/>
+        <a:font script="Khmr" typeface="MoolBoran"/>
+        <a:font script="Knda" typeface="Tunga"/>
+        <a:font script="Guru" typeface="Raavi"/>
+        <a:font script="Cans" typeface="Euphemia"/>
+        <a:font script="Cher" typeface="Plantagenet Cherokee"/>
+        <a:font script="Yiii" typeface="Microsoft Yi Baiti"/>
+        <a:font script="Tibt" typeface="Microsoft Himalaya"/>
+        <a:font script="Thaa" typeface="MV Boli"/>
+        <a:font script="Deva" typeface="Mangal"/>
+        <a:font script="Telu" typeface="Gautami"/>
+        <a:font script="Taml" typeface="Latha"/>
+        <a:font script="Syrc" typeface="Estrangelo Edessa"/>
+        <a:font script="Orya" typeface="Kalinga"/>
+        <a:font script="Mlym" typeface="Kartika"/>
+        <a:font script="Laoo" typeface="DokChampa"/>
+        <a:font script="Sinh" typeface="Iskoola Pota"/>
+        <a:font script="Mong" typeface="Mongolian Baiti"/>
+        <a:font script="Viet" typeface="Times New Roman"/>
+        <a:font script="Uigh" typeface="Microsoft Uighur"/>
+        <a:font script="Geor" typeface="Sylfaen"/>
+        <a:font script="Armn" typeface="Arial"/>
+        <a:font script="Bugi" typeface="Leelawadee UI"/>
+        <a:font script="Bopo" typeface="Microsoft JhengHei"/>
+        <a:font script="Java" typeface="Javanese Text"/>
+        <a:font script="Lisu" typeface="Segoe UI"/>
+        <a:font script="Mymr" typeface="Myanmar Text"/>
+        <a:font script="Nkoo" typeface="Ebrima"/>
+        <a:font script="Olck" typeface="Nirmala UI"/>
+        <a:font script="Osma" typeface="Ebrima"/>
+        <a:font script="Phag" typeface="Phagspa"/>
+        <a:font script="Syrn" typeface="Estrangelo Edessa"/>
+        <a:font script="Syrj" typeface="Estrangelo Edessa"/>
+        <a:font script="Syre" typeface="Estrangelo Edessa"/>
+        <a:font script="Sora" typeface="Nirmala UI"/>
+        <a:font script="Tale" typeface="Microsoft Tai Le"/>
+        <a:font script="Talu" typeface="Microsoft New Tai Lue"/>
+        <a:font script="Tfng" typeface="Ebrima"/>
+      </a:majorFont>
+      <a:minorFont>
+        <a:latin typeface="Aptos" panose="02110004020202020204"/>
+        <a:ea typeface=""/>
+        <a:cs typeface=""/>
+        <a:font script="Jpan" typeface="游ゴシック"/>
+        <a:font script="Hang" typeface="맑은 고딕"/>
+        <a:font script="Hans" typeface="等线"/>
+        <a:font script="Hant" typeface="新細明體"/>
+        <a:font script="Arab" typeface="Arial"/>
+        <a:font script="Hebr" typeface="Arial"/>
+        <a:font script="Thai" typeface="Cordia New"/>
+        <a:font script="Ethi" typeface="Nyala"/>
+        <a:font script="Beng" typeface="Vrinda"/>
+        <a:font script="Gujr" typeface="Shruti"/>
+        <a:font script="Khmr" typeface="DaunPenh"/>
+        <a:font script="Knda" typeface="Tunga"/>
+        <a:font script="Guru" typeface="Raavi"/>
+        <a:font script="Cans" typeface="Euphemia"/>
+        <a:font script="Cher" typeface="Plantagenet Cherokee"/>
+        <a:font script="Yiii" typeface="Microsoft Yi Baiti"/>
+        <a:font script="Tibt" typeface="Microsoft Himalaya"/>
+        <a:font script="Thaa" typeface="MV Boli"/>
+        <a:font script="Deva" typeface="Mangal"/>
+        <a:font script="Telu" typeface="Gautami"/>
+        <a:font script="Taml" typeface="Latha"/>
+        <a:font script="Syrc" typeface="Estrangelo Edessa"/>
+        <a:font script="Orya" typeface="Kalinga"/>
+        <a:font script="Mlym" typeface="Kartika"/>
+        <a:font script="Laoo" typeface="DokChampa"/>
+        <a:font script="Sinh" typeface="Iskoola Pota"/>
+        <a:font script="Mong" typeface="Mongolian Baiti"/>
+        <a:font script="Viet" typeface="Arial"/>
+        <a:font script="Uigh" typeface="Microsoft Uighur"/>
+        <a:font script="Geor" typeface="Sylfaen"/>
+        <a:font script="Armn" typeface="Arial"/>
+        <a:font script="Bugi" typeface="Leelawadee UI"/>
+        <a:font script="Bopo" typeface="Microsoft JhengHei"/>
+        <a:font script="Java" typeface="Javanese Text"/>
+        <a:font script="Lisu" typeface="Segoe UI"/>
+        <a:font script="Mymr" typeface="Myanmar Text"/>
+        <a:font script="Nkoo" typeface="Ebrima"/>
+        <a:font script="Olck" typeface="Nirmala UI"/>
+        <a:font script="Osma" typeface="Ebrima"/>
+        <a:font script="Phag" typeface="Phagspa"/>
+        <a:font script="Syrn" typeface="Estrangelo Edessa"/>
+        <a:font script="Syrj" typeface="Estrangelo Edessa"/>
+        <a:font script="Syre" typeface="Estrangelo Edessa"/>
+        <a:font script="Sora" typeface="Nirmala UI"/>
+        <a:font script="Tale" typeface="Microsoft Tai Le"/>
+        <a:font script="Talu" typeface="Microsoft New Tai Lue"/>
+        <a:font script="Tfng" typeface="Ebrima"/>
+      </a:minorFont>
+    </a:fontScheme>
+    <a:fmtScheme name="Office">
+      <a:fillStyleLst>
+        <a:solidFill>
+          <a:schemeClr val="phClr"/>
+        </a:solidFill>
+        <a:gradFill rotWithShape="1">
+          <a:gsLst>
+            <a:gs pos="0">
+              <a:schemeClr val="phClr">
+                <a:lumMod val="110000"/>
+                <a:satMod val="105000"/>
+                <a:tint val="67000"/>
+              </a:schemeClr>
+            </a:gs>
+            <a:gs pos="50000">
+              <a:schemeClr val="phClr">
+                <a:lumMod val="105000"/>
+                <a:satMod val="103000"/>
+                <a:tint val="73000"/>
+              </a:schemeClr>
+            </a:gs>
+            <a:gs pos="100000">
+              <a:schemeClr val="phClr">
+                <a:lumMod val="105000"/>
+                <a:satMod val="109000"/>
+                <a:tint val="81000"/>
+              </a:schemeClr>
+            </a:gs>
+          </a:gsLst>
+          <a:lin ang="5400000" scaled="0"/>
+        </a:gradFill>
+        <a:gradFill rotWithShape="1">
+          <a:gsLst>
+            <a:gs pos="0">
+              <a:schemeClr val="phClr">
+                <a:satMod val="103000"/>
+                <a:lumMod val="102000"/>
+                <a:tint val="94000"/>
+              </a:schemeClr>
+            </a:gs>
+            <a:gs pos="50000">
+              <a:schemeClr val="phClr">
+                <a:satMod val="110000"/>
+                <a:lumMod val="100000"/>
+                <a:shade val="100000"/>
+              </a:schemeClr>
+            </a:gs>
+            <a:gs pos="100000">
+              <a:schemeClr val="phClr">
+                <a:lumMod val="99000"/>
+                <a:satMod val="120000"/>
+                <a:shade val="78000"/>
+              </a:schemeClr>
+            </a:gs>
+          </a:gsLst>
+          <a:lin ang="5400000" scaled="0"/>
+        </a:gradFill>
+      </a:fillStyleLst>
+      <a:lnStyleLst>
+        <a:ln w="12700" cap="flat" cmpd="sng" algn="ctr">
+          <a:solidFill>
+            <a:schemeClr val="phClr"/>
+          </a:solidFill>
+          <a:prstDash val="solid"/>
+          <a:miter lim="800000"/>
+        </a:ln>
+        <a:ln w="19050" cap="flat" cmpd="sng" algn="ctr">
+          <a:solidFill>
+            <a:schemeClr val="phClr"/>
+          </a:solidFill>
+          <a:prstDash val="solid"/>
+          <a:miter lim="800000"/>
+        </a:ln>
+        <a:ln w="25400" cap="flat" cmpd="sng" algn="ctr">
+          <a:solidFill>
+            <a:schemeClr val="phClr"/>
+          </a:solidFill>
+          <a:prstDash val="solid"/>
+          <a:miter lim="800000"/>
+        </a:ln>
+      </a:lnStyleLst>
+      <a:effectStyleLst>
+        <a:effectStyle>
+          <a:effectLst/>
+        </a:effectStyle>
+        <a:effectStyle>
+          <a:effectLst/>
+        </a:effectStyle>
+        <a:effectStyle>
+          <a:effectLst>
+            <a:outerShdw blurRad="57150" dist="19050" dir="5400000" algn="ctr" rotWithShape="0">
+              <a:srgbClr val="000000">
+                <a:alpha val="63000"/>
+              </a:srgbClr>
+            </a:outerShdw>
+          </a:effectLst>
+        </a:effectStyle>
+      </a:effectStyleLst>
+      <a:bgFillStyleLst>
+        <a:solidFill>
+          <a:schemeClr val="phClr"/>
+        </a:solidFill>
+        <a:solidFill>
+          <a:schemeClr val="phClr">
+            <a:tint val="95000"/>
+            <a:satMod val="170000"/>
+          </a:schemeClr>
+        </a:solidFill>
+        <a:gradFill rotWithShape="1">
+          <a:gsLst>
+            <a:gs pos="0">
+              <a:schemeClr val="phClr">
+                <a:tint val="93000"/>
+                <a:satMod val="150000"/>
+                <a:shade val="98000"/>
+                <a:lumMod val="102000"/>
+              </a:schemeClr>
+            </a:gs>
+            <a:gs pos="50000">
+              <a:schemeClr val="phClr">
+                <a:tint val="98000"/>
+                <a:satMod val="130000"/>
+                <a:shade val="90000"/>
+                <a:lumMod val="103000"/>
+              </a:schemeClr>
+            </a:gs>
+            <a:gs pos="100000">
+              <a:schemeClr val="phClr">
+                <a:shade val="63000"/>
+                <a:satMod val="120000"/>
+              </a:schemeClr>
+            </a:gs>
+          </a:gsLst>
+          <a:lin ang="5400000" scaled="0"/>
+        </a:gradFill>
+      </a:bgFillStyleLst>
+    </a:fmtScheme>
+  </a:themeElements>
+  <a:objectDefaults>
+    <a:lnDef>
+      <a:spPr/>
+      <a:bodyPr/>
+      <a:lstStyle/>
+      <a:style>
+        <a:lnRef idx="2">
+          <a:schemeClr val="accent1"/>
+        </a:lnRef>
+        <a:fillRef idx="0">
+          <a:schemeClr val="accent1"/>
+        </a:fillRef>
+        <a:effectRef idx="1">
+          <a:schemeClr val="accent1"/>
+        </a:effectRef>
+        <a:fontRef idx="minor">
+          <a:schemeClr val="tx1"/>
+        </a:fontRef>
+      </a:style>
+    </a:lnDef>
+  </a:objectDefaults>
+  <a:extraClrSchemeLst/>
+  <a:extLst>
+    <a:ext uri="{05A4C25C-085E-4340-85A3-A5531E510DB2}">
+      <thm15:themeFamily xmlns:thm15="http://schemas.microsoft.com/office/thememl/2012/main" name="Office Theme" id="{2E142A2C-CD16-42D6-873A-C26D2A0506FA}" vid="{1BDDFF52-6CD6-40A5-AB3C-68EB2F1E4D0A}"/>
+    </a:ext>
+  </a:extLst>
+</a:theme>
 </file>
</xml_diff>